<commit_message>
feat(entregables): actualizar pitch video (1080p y 4K) y pitch deck (PDF y PPTX) con identidad Sobra
</commit_message>
<xml_diff>
--- a/entregables/03-pitch-deck.pptx
+++ b/entregables/03-pitch-deck.pptx
@@ -12,6 +12,7 @@
     <p:sldId id="260" r:id="rId12"/>
     <p:sldId id="261" r:id="rId13"/>
     <p:sldId id="262" r:id="rId14"/>
+    <p:sldId id="263" r:id="rId15"/>
   </p:sldIdLst>
   <p:sldSz cx="12192000" cy="6858000" type="screen4x3"/>
   <p:notesSz cx="6858000" cy="9144000"/>
@@ -508,7 +509,7 @@
           <a:lstStyle/>
           <a:p>
             <a:r>
-              <a:t>Somos el Equipo 13 y traemos Circular NEA: una plataforma para que los residuos de la agroindustria y la foresto-industria de Corrientes encuentren comprador, con números que muestran si el negocio cierra.</a:t>
+              <a:t>Somos el Equipo 13 y creamos Sobra: un mapa de oferta y demanda de biomasa para que los residuos de aserraderos y molinos arroceros de Corrientes encuentren comprador con un número que dice si el negocio cierra.</a:t>
             </a:r>
           </a:p>
         </p:txBody>
@@ -578,7 +579,7 @@
           <a:lstStyle/>
           <a:p>
             <a:r>
-              <a:t>Corrientes produjo el 48,5 % del arroz del país en la campaña 2025/26 y tiene 516.771 hectáreas forestadas. Eso deja montañas de cascarilla y aserrín que en gran parte se queman o se tiran. Estimamos unas 150.000 toneladas de cascarilla por año solo del arroz.</a:t>
+              <a:t>200.000 toneladas por año se queman solo en Santa Rosa, más la cascarilla del primer productor arrocero del país. No es basura: es combustible. Pero el que la tiene no sabe quién la compra ni si el flete se come la ganancia.</a:t>
             </a:r>
           </a:p>
         </p:txBody>
@@ -648,7 +649,7 @@
           <a:lstStyle/>
           <a:p>
             <a:r>
-              <a:t>¿Por qué pasa? La cascarilla suelta pesa 108 kilos por metro cúbico: el camión se llena de aire antes que de peso y el flete se come la ganancia. Además falta información sobre quién compra, y un aserradero chico solo no llena un camión.</a:t>
+              <a:t>La cascarilla suelta pesa tan poco que el camión se llena de aire antes que de carga: más allá de 25 km no conviene. En pellet entra toda la carga y viaja 12 veces más lejos, hasta 310 km.</a:t>
             </a:r>
           </a:p>
         </p:txBody>
@@ -718,7 +719,7 @@
           <a:lstStyle/>
           <a:p>
             <a:r>
-              <a:t>Circular NEA es un mapa con 13 plantas y 10 compradores reales de la región, más lo que publique cualquiera. Elegís tu planta, un comprador y cómo vendés: suelto, compactado o pellet. La app calcula el margen después del flete y lo muestra con un semáforo.</a:t>
+              <a:t>Por eso creamos Sobra: un mapa de oferta y demanda de biomasa que para cada vendedor y cada comprador responde una sola pregunta: ¿cierra el negocio?</a:t>
             </a:r>
           </a:p>
         </p:txBody>
@@ -788,7 +789,7 @@
           <a:lstStyle/>
           <a:p>
             <a:r>
-              <a:t>Este es el momento clave. Con la cascarilla suelta, el radio viable es de unos 25 km por ruta. Pelletizada llega a unos 310 km: unas 12 veces más. El semáforo pasa de rojo a verde y el comprador ve cuánto ahorra frente a su combustible actual. Es un ejemplo del modelo con supuestos estimados, no un resultado de esas empresas; los precios reales se validan en el piloto.</a:t>
+              <a:t>Molinos Ala en Mercedes quiere venderle al Frigorífico Duhalde a 88 km. Si va suelta, pierde 2,26 millones por mes. Con un clic a pellet, viaja 12 veces más lejos y el trato deja casi 2 millones de pesos por mes.</a:t>
             </a:r>
           </a:p>
         </p:txBody>
@@ -858,7 +859,7 @@
           <a:lstStyle/>
           <a:p>
             <a:r>
-              <a:t>Además es un mercado vivo y sin crear cuenta: publicás en un minuto, ves el contacto y el WhatsApp con un click, y la app te avisa cuando aparece un negocio compatible. Las publicaciones entran marcadas como sin verificar.</a:t>
+              <a:t>Y al frigorífico le ahorra 15 millones por mes frente al gas envasado que utiliza hoy. Además, cada número de la plataforma muestra si es real o estimado y enlaza a su fuente oficial.</a:t>
             </a:r>
           </a:p>
         </p:txBody>
@@ -928,7 +929,77 @@
           <a:lstStyle/>
           <a:p>
             <a:r>
-              <a:t>Pueden probarla ahora en el link o con el QR. Para el piloto buscamos cinco aserraderos y dos molinos con sus datos reales. La idea y el diseño son del Equipo 13; la programación tuvo asistencia de IA. Gracias.</a:t>
+              <a:t>En Sobra publicás lo que tenés o buscás en un minuto sin crear cuenta, ves el contacto directo y recibís alertas. Para el aserradero es ingreso, para la industria energía barata y un solo acuerdo evita 500 toneladas de CO2 al año.</a:t>
+            </a:r>
+          </a:p>
+        </p:txBody>
+      </p:sp>
+      <p:sp>
+        <p:nvSpPr>
+          <p:cNvPr id="4" name="Slide Number Placeholder 3"/>
+          <p:cNvSpPr>
+            <a:spLocks noGrp="1"/>
+          </p:cNvSpPr>
+          <p:nvPr>
+            <p:ph type="sldNum" idx="5" sz="quarter"/>
+          </p:nvPr>
+        </p:nvSpPr>
+        <p:spPr/>
+      </p:sp>
+    </p:spTree>
+  </p:cSld>
+  <p:clrMapOvr>
+    <a:masterClrMapping/>
+  </p:clrMapOvr>
+</p:notes>
+</file>
+
+<file path=ppt/notesSlides/notesSlide8.xml><?xml version="1.0" encoding="utf-8"?>
+<p:notes xmlns:a="http://schemas.openxmlformats.org/drawingml/2006/main" xmlns:p="http://schemas.openxmlformats.org/presentationml/2006/main" xmlns:r="http://schemas.openxmlformats.org/officeDocument/2006/relationships">
+  <p:cSld>
+    <p:spTree>
+      <p:nvGrpSpPr>
+        <p:cNvPr id="1" name=""/>
+        <p:cNvGrpSpPr/>
+        <p:nvPr/>
+      </p:nvGrpSpPr>
+      <p:grpSpPr>
+        <a:xfrm>
+          <a:off x="0" y="0"/>
+          <a:ext cx="0" cy="0"/>
+          <a:chOff x="0" y="0"/>
+          <a:chExt cx="0" cy="0"/>
+        </a:xfrm>
+      </p:grpSpPr>
+      <p:sp>
+        <p:nvSpPr>
+          <p:cNvPr id="2" name="Slide Image Placeholder 1"/>
+          <p:cNvSpPr>
+            <a:spLocks noGrp="1"/>
+          </p:cNvSpPr>
+          <p:nvPr>
+            <p:ph type="sldImg" idx="2"/>
+          </p:nvPr>
+        </p:nvSpPr>
+        <p:spPr/>
+      </p:sp>
+      <p:sp>
+        <p:nvSpPr>
+          <p:cNvPr id="3" name="Notes Placeholder 2"/>
+          <p:cNvSpPr>
+            <a:spLocks noGrp="1"/>
+          </p:cNvSpPr>
+          <p:nvPr>
+            <p:ph type="body" idx="3" sz="quarter"/>
+          </p:nvPr>
+        </p:nvSpPr>
+        <p:spPr/>
+        <p:txBody>
+          <a:bodyPr/>
+          <a:lstStyle/>
+          <a:p>
+            <a:r>
+              <a:t>Por esto los invitamos a probar Sobra, que pasa del residuo al mercado, con un número que te cierra.</a:t>
             </a:r>
           </a:p>
         </p:txBody>
@@ -3930,7 +4001,7 @@
     <p:bg>
       <p:bgPr>
         <a:solidFill>
-          <a:srgbClr val="F7F8F7"/>
+          <a:srgbClr val="0B1640"/>
         </a:solidFill>
         <a:effectLst/>
       </p:bgPr>
@@ -3959,8 +4030,8 @@
         </p:blipFill>
         <p:spPr>
           <a:xfrm>
-            <a:off x="711200" y="635000"/>
-            <a:ext cx="952500" cy="952500"/>
+            <a:off x="660400" y="660400"/>
+            <a:ext cx="711200" cy="711200"/>
           </a:xfrm>
           <a:prstGeom prst="rect">
             <a:avLst/>
@@ -3975,8 +4046,8 @@
         </p:nvSpPr>
         <p:spPr>
           <a:xfrm>
-            <a:off x="711200" y="1663700"/>
-            <a:ext cx="5588000" cy="2540000"/>
+            <a:off x="1524000" y="635000"/>
+            <a:ext cx="3556000" cy="889000"/>
           </a:xfrm>
           <a:prstGeom prst="rect">
             <a:avLst/>
@@ -3991,33 +4062,26 @@
           <a:p>
             <a:pPr algn="l">
               <a:lnSpc>
-                <a:spcPct val="95000"/>
+                <a:spcPct val="105000"/>
               </a:lnSpc>
             </a:pPr>
             <a:r>
-              <a:rPr sz="7500" b="1" spc="-188">
-                <a:solidFill>
-                  <a:srgbClr val="141A17"/>
-                </a:solidFill>
-                <a:latin typeface="Geist"/>
+              <a:rPr sz="4800" b="1" spc="-96">
+                <a:solidFill>
+                  <a:srgbClr val="FFFFFF"/>
+                </a:solidFill>
+                <a:latin typeface="Segoe UI"/>
               </a:rPr>
-              <a:t>Circular</a:t>
-            </a:r>
-          </a:p>
-          <a:p>
-            <a:pPr algn="l">
-              <a:lnSpc>
-                <a:spcPct val="95000"/>
-              </a:lnSpc>
-            </a:pPr>
-            <a:r>
-              <a:rPr sz="7500" b="1" spc="-188">
-                <a:solidFill>
-                  <a:srgbClr val="447D5F"/>
-                </a:solidFill>
-                <a:latin typeface="Geist"/>
+              <a:t>Sobra</a:t>
+            </a:r>
+            <a:r>
+              <a:rPr sz="4800" b="1" spc="-96">
+                <a:solidFill>
+                  <a:srgbClr val="7AA7FF"/>
+                </a:solidFill>
+                <a:latin typeface="Segoe UI"/>
               </a:rPr>
-              <a:t>NEA</a:t>
+              <a:t>.</a:t>
             </a:r>
           </a:p>
         </p:txBody>
@@ -4030,47 +4094,8 @@
         </p:nvSpPr>
         <p:spPr>
           <a:xfrm>
-            <a:off x="711200" y="4292600"/>
-            <a:ext cx="5588000" cy="635000"/>
-          </a:xfrm>
-          <a:prstGeom prst="rect">
-            <a:avLst/>
-          </a:prstGeom>
-          <a:noFill/>
-        </p:spPr>
-        <p:txBody>
-          <a:bodyPr wrap="square" lIns="0" rIns="0" tIns="0" bIns="0" anchor="t">
-            <a:noAutofit/>
-          </a:bodyPr>
-          <a:lstStyle/>
-          <a:p>
-            <a:pPr algn="l">
-              <a:lnSpc>
-                <a:spcPct val="110000"/>
-              </a:lnSpc>
-            </a:pPr>
-            <a:r>
-              <a:rPr sz="3200" b="0">
-                <a:solidFill>
-                  <a:srgbClr val="141A17"/>
-                </a:solidFill>
-                <a:latin typeface="Geist"/>
-              </a:rPr>
-              <a:t>El residuo que vuelve ingreso</a:t>
-            </a:r>
-          </a:p>
-        </p:txBody>
-      </p:sp>
-      <p:sp>
-        <p:nvSpPr>
-          <p:cNvPr id="5" name="TextBox 4"/>
-          <p:cNvSpPr txBox="1"/>
-          <p:nvPr/>
-        </p:nvSpPr>
-        <p:spPr>
-          <a:xfrm>
-            <a:off x="711200" y="5080000"/>
-            <a:ext cx="5588000" cy="444500"/>
+            <a:off x="660400" y="1727200"/>
+            <a:ext cx="4699000" cy="1651000"/>
           </a:xfrm>
           <a:prstGeom prst="rect">
             <a:avLst/>
@@ -4089,38 +4114,15 @@
               </a:lnSpc>
             </a:pPr>
             <a:r>
-              <a:rPr sz="2400" b="1">
-                <a:solidFill>
-                  <a:srgbClr val="141A17"/>
-                </a:solidFill>
-                <a:latin typeface="Geist"/>
+              <a:rPr sz="4400" b="1" spc="-88">
+                <a:solidFill>
+                  <a:srgbClr val="FFFFFF"/>
+                </a:solidFill>
+                <a:latin typeface="Segoe UI"/>
               </a:rPr>
-              <a:t>Equipo 13</a:t>
-            </a:r>
-          </a:p>
-        </p:txBody>
-      </p:sp>
-      <p:sp>
-        <p:nvSpPr>
-          <p:cNvPr id="6" name="TextBox 5"/>
-          <p:cNvSpPr txBox="1"/>
-          <p:nvPr/>
-        </p:nvSpPr>
-        <p:spPr>
-          <a:xfrm>
-            <a:off x="711200" y="5651500"/>
-            <a:ext cx="5588000" cy="381000"/>
-          </a:xfrm>
-          <a:prstGeom prst="rect">
-            <a:avLst/>
-          </a:prstGeom>
-          <a:noFill/>
-        </p:spPr>
-        <p:txBody>
-          <a:bodyPr wrap="square" lIns="0" rIns="0" tIns="0" bIns="0" anchor="t">
-            <a:noAutofit/>
-          </a:bodyPr>
-          <a:lstStyle/>
+              <a:t>Del residuo</a:t>
+            </a:r>
+          </a:p>
           <a:p>
             <a:pPr algn="l">
               <a:lnSpc>
@@ -4128,11 +4130,128 @@
               </a:lnSpc>
             </a:pPr>
             <a:r>
-              <a:rPr sz="2000" b="0" spc="160">
-                <a:solidFill>
-                  <a:srgbClr val="55605B"/>
-                </a:solidFill>
-                <a:latin typeface="Geist Mono"/>
+              <a:rPr sz="4400" b="1" spc="-88">
+                <a:solidFill>
+                  <a:srgbClr val="7AA7FF"/>
+                </a:solidFill>
+                <a:latin typeface="Segoe UI"/>
+              </a:rPr>
+              <a:t>al mercado.</a:t>
+            </a:r>
+          </a:p>
+        </p:txBody>
+      </p:sp>
+      <p:sp>
+        <p:nvSpPr>
+          <p:cNvPr id="5" name="TextBox 4"/>
+          <p:cNvSpPr txBox="1"/>
+          <p:nvPr/>
+        </p:nvSpPr>
+        <p:spPr>
+          <a:xfrm>
+            <a:off x="660400" y="3530600"/>
+            <a:ext cx="4699000" cy="1270000"/>
+          </a:xfrm>
+          <a:prstGeom prst="rect">
+            <a:avLst/>
+          </a:prstGeom>
+          <a:noFill/>
+        </p:spPr>
+        <p:txBody>
+          <a:bodyPr wrap="square" lIns="0" rIns="0" tIns="0" bIns="0" anchor="t">
+            <a:noAutofit/>
+          </a:bodyPr>
+          <a:lstStyle/>
+          <a:p>
+            <a:pPr algn="l">
+              <a:lnSpc>
+                <a:spcPct val="112000"/>
+              </a:lnSpc>
+            </a:pPr>
+            <a:r>
+              <a:rPr sz="2200" b="0">
+                <a:solidFill>
+                  <a:srgbClr val="D3DEF3"/>
+                </a:solidFill>
+                <a:latin typeface="Segoe UI"/>
+              </a:rPr>
+              <a:t>El mapa que dice si tu biomasa cierra después del flete.</a:t>
+            </a:r>
+          </a:p>
+        </p:txBody>
+      </p:sp>
+      <p:sp>
+        <p:nvSpPr>
+          <p:cNvPr id="6" name="TextBox 5"/>
+          <p:cNvSpPr txBox="1"/>
+          <p:nvPr/>
+        </p:nvSpPr>
+        <p:spPr>
+          <a:xfrm>
+            <a:off x="660400" y="4953000"/>
+            <a:ext cx="4699000" cy="457200"/>
+          </a:xfrm>
+          <a:prstGeom prst="rect">
+            <a:avLst/>
+          </a:prstGeom>
+          <a:noFill/>
+        </p:spPr>
+        <p:txBody>
+          <a:bodyPr wrap="square" lIns="0" rIns="0" tIns="0" bIns="0" anchor="t">
+            <a:noAutofit/>
+          </a:bodyPr>
+          <a:lstStyle/>
+          <a:p>
+            <a:pPr algn="l">
+              <a:lnSpc>
+                <a:spcPct val="105000"/>
+              </a:lnSpc>
+            </a:pPr>
+            <a:r>
+              <a:rPr sz="2400" b="1">
+                <a:solidFill>
+                  <a:srgbClr val="FFFFFF"/>
+                </a:solidFill>
+                <a:latin typeface="Segoe UI"/>
+              </a:rPr>
+              <a:t>Equipo 13</a:t>
+            </a:r>
+          </a:p>
+        </p:txBody>
+      </p:sp>
+      <p:sp>
+        <p:nvSpPr>
+          <p:cNvPr id="7" name="TextBox 6"/>
+          <p:cNvSpPr txBox="1"/>
+          <p:nvPr/>
+        </p:nvSpPr>
+        <p:spPr>
+          <a:xfrm>
+            <a:off x="660400" y="5537200"/>
+            <a:ext cx="4699000" cy="406400"/>
+          </a:xfrm>
+          <a:prstGeom prst="rect">
+            <a:avLst/>
+          </a:prstGeom>
+          <a:noFill/>
+        </p:spPr>
+        <p:txBody>
+          <a:bodyPr wrap="square" lIns="0" rIns="0" tIns="0" bIns="0" anchor="t">
+            <a:noAutofit/>
+          </a:bodyPr>
+          <a:lstStyle/>
+          <a:p>
+            <a:pPr algn="l">
+              <a:lnSpc>
+                <a:spcPct val="105000"/>
+              </a:lnSpc>
+            </a:pPr>
+            <a:r>
+              <a:rPr sz="2000" b="1" spc="80">
+                <a:solidFill>
+                  <a:srgbClr val="7AA7FF"/>
+                </a:solidFill>
+                <a:latin typeface="Consolas"/>
               </a:rPr>
               <a:t>IDEATHON NEA TECH 2026</a:t>
             </a:r>
@@ -4141,7 +4260,7 @@
       </p:sp>
       <p:pic>
         <p:nvPicPr>
-          <p:cNvPr id="7" name="Picture 6" descr="03-pellet.jpg"/>
+          <p:cNvPr id="8" name="Picture 7" descr="00-portada.png"/>
           <p:cNvPicPr>
             <a:picLocks noChangeAspect="1"/>
           </p:cNvPicPr>
@@ -4149,22 +4268,22 @@
         </p:nvPicPr>
         <p:blipFill>
           <a:blip r:embed="rId3"/>
-          <a:srcRect l="9591" r="17812"/>
+          <a:srcRect/>
           <a:stretch>
             <a:fillRect/>
           </a:stretch>
         </p:blipFill>
         <p:spPr>
           <a:xfrm>
-            <a:off x="6604000" y="1143000"/>
-            <a:ext cx="4876800" cy="5168900"/>
-          </a:xfrm>
-          <a:prstGeom prst="rect">
-            <a:avLst/>
-          </a:prstGeom>
-          <a:ln w="9525">
+            <a:off x="5689600" y="1651000"/>
+            <a:ext cx="5892800" cy="3314700"/>
+          </a:xfrm>
+          <a:prstGeom prst="rect">
+            <a:avLst/>
+          </a:prstGeom>
+          <a:ln w="19050">
             <a:solidFill>
-              <a:srgbClr val="DFE4E1"/>
+              <a:srgbClr val="2150E8"/>
             </a:solidFill>
           </a:ln>
         </p:spPr>
@@ -4183,7 +4302,7 @@
     <p:bg>
       <p:bgPr>
         <a:solidFill>
-          <a:srgbClr val="F7F8F7"/>
+          <a:srgbClr val="EEF3FD"/>
         </a:solidFill>
         <a:effectLst/>
       </p:bgPr>
@@ -4195,52 +4314,105 @@
         <p:nvPr/>
       </p:nvGrpSpPr>
       <p:grpSpPr/>
-      <p:pic>
-        <p:nvPicPr>
-          <p:cNvPr id="2" name="Picture 1" descr="app-light.png"/>
-          <p:cNvPicPr>
-            <a:picLocks noChangeAspect="1"/>
-          </p:cNvPicPr>
-          <p:nvPr/>
-        </p:nvPicPr>
-        <p:blipFill>
-          <a:blip r:embed="rId2"/>
-          <a:srcRect t="5000" b="5000"/>
-          <a:stretch>
-            <a:fillRect/>
-          </a:stretch>
-        </p:blipFill>
-        <p:spPr>
-          <a:xfrm>
-            <a:off x="0" y="0"/>
-            <a:ext cx="12192000" cy="6858000"/>
-          </a:xfrm>
-          <a:prstGeom prst="rect">
-            <a:avLst/>
-          </a:prstGeom>
-        </p:spPr>
-      </p:pic>
-      <p:sp>
-        <p:nvSpPr>
-          <p:cNvPr id="3" name="Rectangle 2"/>
+      <p:sp>
+        <p:nvSpPr>
+          <p:cNvPr id="2" name="TextBox 1"/>
+          <p:cNvSpPr txBox="1"/>
+          <p:nvPr/>
+        </p:nvSpPr>
+        <p:spPr>
+          <a:xfrm>
+            <a:off x="660400" y="609600"/>
+            <a:ext cx="7620000" cy="406400"/>
+          </a:xfrm>
+          <a:prstGeom prst="rect">
+            <a:avLst/>
+          </a:prstGeom>
+          <a:noFill/>
+        </p:spPr>
+        <p:txBody>
+          <a:bodyPr wrap="square" lIns="0" rIns="0" tIns="0" bIns="0" anchor="t">
+            <a:noAutofit/>
+          </a:bodyPr>
+          <a:lstStyle/>
+          <a:p>
+            <a:pPr algn="l">
+              <a:lnSpc>
+                <a:spcPct val="105000"/>
+              </a:lnSpc>
+            </a:pPr>
+            <a:r>
+              <a:rPr sz="2000" b="1" spc="80">
+                <a:solidFill>
+                  <a:srgbClr val="2150E8"/>
+                </a:solidFill>
+                <a:latin typeface="Consolas"/>
+              </a:rPr>
+              <a:t>01 · EL PROBLEMA</a:t>
+            </a:r>
+          </a:p>
+        </p:txBody>
+      </p:sp>
+      <p:sp>
+        <p:nvSpPr>
+          <p:cNvPr id="3" name="TextBox 2"/>
+          <p:cNvSpPr txBox="1"/>
+          <p:nvPr/>
+        </p:nvSpPr>
+        <p:spPr>
+          <a:xfrm>
+            <a:off x="660400" y="1143000"/>
+            <a:ext cx="10160000" cy="825500"/>
+          </a:xfrm>
+          <a:prstGeom prst="rect">
+            <a:avLst/>
+          </a:prstGeom>
+          <a:noFill/>
+        </p:spPr>
+        <p:txBody>
+          <a:bodyPr wrap="square" lIns="0" rIns="0" tIns="0" bIns="0" anchor="t">
+            <a:noAutofit/>
+          </a:bodyPr>
+          <a:lstStyle/>
+          <a:p>
+            <a:pPr algn="l">
+              <a:lnSpc>
+                <a:spcPct val="105000"/>
+              </a:lnSpc>
+            </a:pPr>
+            <a:r>
+              <a:rPr sz="4200" b="1" spc="-84">
+                <a:solidFill>
+                  <a:srgbClr val="0A1433"/>
+                </a:solidFill>
+                <a:latin typeface="Segoe UI"/>
+              </a:rPr>
+              <a:t>Se quema lo que es combustible</a:t>
+            </a:r>
+          </a:p>
+        </p:txBody>
+      </p:sp>
+      <p:sp>
+        <p:nvSpPr>
+          <p:cNvPr id="4" name="Rectangle 3"/>
           <p:cNvSpPr/>
           <p:nvPr/>
         </p:nvSpPr>
         <p:spPr>
           <a:xfrm>
-            <a:off x="0" y="0"/>
-            <a:ext cx="12192000" cy="6858000"/>
+            <a:off x="660400" y="2159000"/>
+            <a:ext cx="3429000" cy="2794000"/>
           </a:xfrm>
           <a:prstGeom prst="rect">
             <a:avLst/>
           </a:prstGeom>
           <a:solidFill>
-            <a:srgbClr val="F7F8F7">
-              <a:alpha val="90000"/>
-            </a:srgbClr>
+            <a:srgbClr val="FFFFFF"/>
           </a:solidFill>
-          <a:ln>
-            <a:noFill/>
+          <a:ln w="12700">
+            <a:solidFill>
+              <a:srgbClr val="D3DEF3"/>
+            </a:solidFill>
           </a:ln>
           <a:effectLst/>
         </p:spPr>
@@ -4268,14 +4440,14 @@
       </p:sp>
       <p:sp>
         <p:nvSpPr>
-          <p:cNvPr id="4" name="TextBox 3"/>
+          <p:cNvPr id="5" name="TextBox 4"/>
           <p:cNvSpPr txBox="1"/>
           <p:nvPr/>
         </p:nvSpPr>
         <p:spPr>
           <a:xfrm>
-            <a:off x="711200" y="698500"/>
-            <a:ext cx="9906000" cy="952500"/>
+            <a:off x="914400" y="2413000"/>
+            <a:ext cx="2921000" cy="889000"/>
           </a:xfrm>
           <a:prstGeom prst="rect">
             <a:avLst/>
@@ -4290,31 +4462,31 @@
           <a:p>
             <a:pPr algn="l">
               <a:lnSpc>
-                <a:spcPct val="100000"/>
+                <a:spcPct val="105000"/>
               </a:lnSpc>
             </a:pPr>
             <a:r>
-              <a:rPr sz="5400" b="1" spc="-135">
-                <a:solidFill>
-                  <a:srgbClr val="141A17"/>
-                </a:solidFill>
-                <a:latin typeface="Geist"/>
+              <a:rPr sz="4200" b="1">
+                <a:solidFill>
+                  <a:srgbClr val="B5402A"/>
+                </a:solidFill>
+                <a:latin typeface="Consolas"/>
               </a:rPr>
-              <a:t>Se quema lo que vale</a:t>
-            </a:r>
-          </a:p>
-        </p:txBody>
-      </p:sp>
-      <p:sp>
-        <p:nvSpPr>
-          <p:cNvPr id="5" name="TextBox 4"/>
+              <a:t>200 mil</a:t>
+            </a:r>
+          </a:p>
+        </p:txBody>
+      </p:sp>
+      <p:sp>
+        <p:nvSpPr>
+          <p:cNvPr id="6" name="TextBox 5"/>
           <p:cNvSpPr txBox="1"/>
           <p:nvPr/>
         </p:nvSpPr>
         <p:spPr>
           <a:xfrm>
-            <a:off x="711200" y="2349500"/>
-            <a:ext cx="5207000" cy="1498600"/>
+            <a:off x="914400" y="3429000"/>
+            <a:ext cx="2921000" cy="1333500"/>
           </a:xfrm>
           <a:prstGeom prst="rect">
             <a:avLst/>
@@ -4329,40 +4501,77 @@
           <a:p>
             <a:pPr algn="l">
               <a:lnSpc>
-                <a:spcPct val="100000"/>
+                <a:spcPct val="112000"/>
               </a:lnSpc>
             </a:pPr>
             <a:r>
-              <a:rPr sz="7500" b="1">
-                <a:solidFill>
-                  <a:srgbClr val="141A17"/>
-                </a:solidFill>
-                <a:latin typeface="Geist Mono"/>
+              <a:rPr sz="2100" b="0">
+                <a:solidFill>
+                  <a:srgbClr val="3D4D7A"/>
+                </a:solidFill>
+                <a:latin typeface="Segoe UI"/>
               </a:rPr>
-              <a:t>48,5</a:t>
-            </a:r>
-            <a:r>
-              <a:rPr sz="3600" b="1">
-                <a:solidFill>
-                  <a:srgbClr val="141A17"/>
-                </a:solidFill>
-                <a:latin typeface="Geist Mono"/>
-              </a:rPr>
-              <a:t> %</a:t>
-            </a:r>
-          </a:p>
-        </p:txBody>
-      </p:sp>
-      <p:sp>
-        <p:nvSpPr>
-          <p:cNvPr id="6" name="TextBox 5"/>
+              <a:t>toneladas al año se queman solo en Santa Rosa.</a:t>
+            </a:r>
+          </a:p>
+        </p:txBody>
+      </p:sp>
+      <p:sp>
+        <p:nvSpPr>
+          <p:cNvPr id="7" name="Rectangle 6"/>
+          <p:cNvSpPr/>
+          <p:nvPr/>
+        </p:nvSpPr>
+        <p:spPr>
+          <a:xfrm>
+            <a:off x="4381500" y="2159000"/>
+            <a:ext cx="3429000" cy="2794000"/>
+          </a:xfrm>
+          <a:prstGeom prst="rect">
+            <a:avLst/>
+          </a:prstGeom>
+          <a:solidFill>
+            <a:srgbClr val="FFFFFF"/>
+          </a:solidFill>
+          <a:ln w="12700">
+            <a:solidFill>
+              <a:srgbClr val="D3DEF3"/>
+            </a:solidFill>
+          </a:ln>
+          <a:effectLst/>
+        </p:spPr>
+        <p:style>
+          <a:lnRef idx="1">
+            <a:schemeClr val="accent1"/>
+          </a:lnRef>
+          <a:fillRef idx="3">
+            <a:schemeClr val="accent1"/>
+          </a:fillRef>
+          <a:effectRef idx="2">
+            <a:schemeClr val="accent1"/>
+          </a:effectRef>
+          <a:fontRef idx="minor">
+            <a:schemeClr val="lt1"/>
+          </a:fontRef>
+        </p:style>
+        <p:txBody>
+          <a:bodyPr rtlCol="0" anchor="ctr"/>
+          <a:lstStyle/>
+          <a:p>
+            <a:pPr algn="ctr"/>
+          </a:p>
+        </p:txBody>
+      </p:sp>
+      <p:sp>
+        <p:nvSpPr>
+          <p:cNvPr id="8" name="TextBox 7"/>
           <p:cNvSpPr txBox="1"/>
           <p:nvPr/>
         </p:nvSpPr>
         <p:spPr>
           <a:xfrm>
-            <a:off x="711200" y="3937000"/>
-            <a:ext cx="4953000" cy="889000"/>
+            <a:off x="4635500" y="2413000"/>
+            <a:ext cx="2921000" cy="889000"/>
           </a:xfrm>
           <a:prstGeom prst="rect">
             <a:avLst/>
@@ -4377,31 +4586,31 @@
           <a:p>
             <a:pPr algn="l">
               <a:lnSpc>
-                <a:spcPct val="115000"/>
+                <a:spcPct val="105000"/>
               </a:lnSpc>
             </a:pPr>
             <a:r>
-              <a:rPr sz="2200" b="0">
-                <a:solidFill>
-                  <a:srgbClr val="55605B"/>
-                </a:solidFill>
-                <a:latin typeface="Geist"/>
+              <a:rPr sz="4200" b="1">
+                <a:solidFill>
+                  <a:srgbClr val="2150E8"/>
+                </a:solidFill>
+                <a:latin typeface="Consolas"/>
               </a:rPr>
-              <a:t>del arroz del país sale de Corrientes</a:t>
-            </a:r>
-          </a:p>
-        </p:txBody>
-      </p:sp>
-      <p:sp>
-        <p:nvSpPr>
-          <p:cNvPr id="7" name="TextBox 6"/>
+              <a:t>48,5 %</a:t>
+            </a:r>
+          </a:p>
+        </p:txBody>
+      </p:sp>
+      <p:sp>
+        <p:nvSpPr>
+          <p:cNvPr id="9" name="TextBox 8"/>
           <p:cNvSpPr txBox="1"/>
           <p:nvPr/>
         </p:nvSpPr>
         <p:spPr>
           <a:xfrm>
-            <a:off x="6350000" y="2349500"/>
-            <a:ext cx="5130800" cy="1498600"/>
+            <a:off x="4635500" y="3429000"/>
+            <a:ext cx="2921000" cy="1333500"/>
           </a:xfrm>
           <a:prstGeom prst="rect">
             <a:avLst/>
@@ -4416,40 +4625,77 @@
           <a:p>
             <a:pPr algn="l">
               <a:lnSpc>
-                <a:spcPct val="100000"/>
+                <a:spcPct val="112000"/>
               </a:lnSpc>
             </a:pPr>
             <a:r>
-              <a:rPr sz="7500" b="1">
-                <a:solidFill>
-                  <a:srgbClr val="141A17"/>
-                </a:solidFill>
-                <a:latin typeface="Geist Mono"/>
+              <a:rPr sz="2100" b="0">
+                <a:solidFill>
+                  <a:srgbClr val="3D4D7A"/>
+                </a:solidFill>
+                <a:latin typeface="Segoe UI"/>
               </a:rPr>
-              <a:t>516.771</a:t>
-            </a:r>
-            <a:r>
-              <a:rPr sz="3600" b="1">
-                <a:solidFill>
-                  <a:srgbClr val="141A17"/>
-                </a:solidFill>
-                <a:latin typeface="Geist Mono"/>
-              </a:rPr>
-              <a:t> ha</a:t>
-            </a:r>
-          </a:p>
-        </p:txBody>
-      </p:sp>
-      <p:sp>
-        <p:nvSpPr>
-          <p:cNvPr id="8" name="TextBox 7"/>
+              <a:t>del arroz del país sale de Corrientes.</a:t>
+            </a:r>
+          </a:p>
+        </p:txBody>
+      </p:sp>
+      <p:sp>
+        <p:nvSpPr>
+          <p:cNvPr id="10" name="Rectangle 9"/>
+          <p:cNvSpPr/>
+          <p:nvPr/>
+        </p:nvSpPr>
+        <p:spPr>
+          <a:xfrm>
+            <a:off x="8102600" y="2159000"/>
+            <a:ext cx="3429000" cy="2794000"/>
+          </a:xfrm>
+          <a:prstGeom prst="rect">
+            <a:avLst/>
+          </a:prstGeom>
+          <a:solidFill>
+            <a:srgbClr val="FFFFFF"/>
+          </a:solidFill>
+          <a:ln w="12700">
+            <a:solidFill>
+              <a:srgbClr val="D3DEF3"/>
+            </a:solidFill>
+          </a:ln>
+          <a:effectLst/>
+        </p:spPr>
+        <p:style>
+          <a:lnRef idx="1">
+            <a:schemeClr val="accent1"/>
+          </a:lnRef>
+          <a:fillRef idx="3">
+            <a:schemeClr val="accent1"/>
+          </a:fillRef>
+          <a:effectRef idx="2">
+            <a:schemeClr val="accent1"/>
+          </a:effectRef>
+          <a:fontRef idx="minor">
+            <a:schemeClr val="lt1"/>
+          </a:fontRef>
+        </p:style>
+        <p:txBody>
+          <a:bodyPr rtlCol="0" anchor="ctr"/>
+          <a:lstStyle/>
+          <a:p>
+            <a:pPr algn="ctr"/>
+          </a:p>
+        </p:txBody>
+      </p:sp>
+      <p:sp>
+        <p:nvSpPr>
+          <p:cNvPr id="11" name="TextBox 10"/>
           <p:cNvSpPr txBox="1"/>
           <p:nvPr/>
         </p:nvSpPr>
         <p:spPr>
           <a:xfrm>
-            <a:off x="6350000" y="3937000"/>
-            <a:ext cx="5130800" cy="889000"/>
+            <a:off x="8356600" y="2413000"/>
+            <a:ext cx="2921000" cy="889000"/>
           </a:xfrm>
           <a:prstGeom prst="rect">
             <a:avLst/>
@@ -4464,31 +4710,31 @@
           <a:p>
             <a:pPr algn="l">
               <a:lnSpc>
-                <a:spcPct val="115000"/>
+                <a:spcPct val="105000"/>
               </a:lnSpc>
             </a:pPr>
             <a:r>
-              <a:rPr sz="2200" b="0">
-                <a:solidFill>
-                  <a:srgbClr val="55605B"/>
-                </a:solidFill>
-                <a:latin typeface="Geist"/>
+              <a:rPr sz="4200" b="1">
+                <a:solidFill>
+                  <a:srgbClr val="0A1433"/>
+                </a:solidFill>
+                <a:latin typeface="Consolas"/>
               </a:rPr>
-              <a:t>forestadas: primera provincia forestal</a:t>
-            </a:r>
-          </a:p>
-        </p:txBody>
-      </p:sp>
-      <p:sp>
-        <p:nvSpPr>
-          <p:cNvPr id="9" name="TextBox 8"/>
+              <a:t>516 mil</a:t>
+            </a:r>
+          </a:p>
+        </p:txBody>
+      </p:sp>
+      <p:sp>
+        <p:nvSpPr>
+          <p:cNvPr id="12" name="TextBox 11"/>
           <p:cNvSpPr txBox="1"/>
           <p:nvPr/>
         </p:nvSpPr>
         <p:spPr>
           <a:xfrm>
-            <a:off x="711200" y="5372100"/>
-            <a:ext cx="9906000" cy="381000"/>
+            <a:off x="8356600" y="3429000"/>
+            <a:ext cx="2921000" cy="1333500"/>
           </a:xfrm>
           <a:prstGeom prst="rect">
             <a:avLst/>
@@ -4503,31 +4749,70 @@
           <a:p>
             <a:pPr algn="l">
               <a:lnSpc>
-                <a:spcPct val="100000"/>
+                <a:spcPct val="112000"/>
               </a:lnSpc>
             </a:pPr>
             <a:r>
-              <a:rPr sz="2000" b="0" spc="160">
-                <a:solidFill>
-                  <a:srgbClr val="3A7254"/>
-                </a:solidFill>
-                <a:latin typeface="Geist Mono"/>
+              <a:rPr sz="2100" b="0">
+                <a:solidFill>
+                  <a:srgbClr val="3D4D7A"/>
+                </a:solidFill>
+                <a:latin typeface="Segoe UI"/>
               </a:rPr>
-              <a:t>DATO REAL · BICHOS DE CAMPO 2025/26 · CONICET 2019</a:t>
+              <a:t>hectáreas forestadas: primera potencia nacional.</a:t>
+            </a:r>
+          </a:p>
+        </p:txBody>
+      </p:sp>
+      <p:sp>
+        <p:nvSpPr>
+          <p:cNvPr id="13" name="TextBox 12"/>
+          <p:cNvSpPr txBox="1"/>
+          <p:nvPr/>
+        </p:nvSpPr>
+        <p:spPr>
+          <a:xfrm>
+            <a:off x="660400" y="5181600"/>
+            <a:ext cx="9144000" cy="825500"/>
+          </a:xfrm>
+          <a:prstGeom prst="rect">
+            <a:avLst/>
+          </a:prstGeom>
+          <a:noFill/>
+        </p:spPr>
+        <p:txBody>
+          <a:bodyPr wrap="square" lIns="0" rIns="0" tIns="0" bIns="0" anchor="t">
+            <a:noAutofit/>
+          </a:bodyPr>
+          <a:lstStyle/>
+          <a:p>
+            <a:pPr algn="l">
+              <a:lnSpc>
+                <a:spcPct val="105000"/>
+              </a:lnSpc>
+            </a:pPr>
+            <a:r>
+              <a:rPr sz="2200" b="1">
+                <a:solidFill>
+                  <a:srgbClr val="0A1433"/>
+                </a:solidFill>
+                <a:latin typeface="Segoe UI"/>
+              </a:rPr>
+              <a:t>Falta saber quién compra y si el camión se come la ganancia.</a:t>
             </a:r>
           </a:p>
         </p:txBody>
       </p:sp>
       <p:pic>
         <p:nvPicPr>
-          <p:cNvPr id="10" name="Picture 9" descr="icon.png"/>
+          <p:cNvPr id="14" name="Picture 13" descr="icon.png"/>
           <p:cNvPicPr>
             <a:picLocks noChangeAspect="1"/>
           </p:cNvPicPr>
           <p:nvPr/>
         </p:nvPicPr>
         <p:blipFill>
-          <a:blip r:embed="rId3"/>
+          <a:blip r:embed="rId2"/>
           <a:srcRect/>
           <a:stretch>
             <a:fillRect/>
@@ -4535,7 +4820,7 @@
         </p:blipFill>
         <p:spPr>
           <a:xfrm>
-            <a:off x="11074400" y="609600"/>
+            <a:off x="11176000" y="558800"/>
             <a:ext cx="406400" cy="406400"/>
           </a:xfrm>
           <a:prstGeom prst="rect">
@@ -4545,14 +4830,14 @@
       </p:pic>
       <p:sp>
         <p:nvSpPr>
-          <p:cNvPr id="11" name="TextBox 10"/>
+          <p:cNvPr id="15" name="TextBox 14"/>
           <p:cNvSpPr txBox="1"/>
           <p:nvPr/>
         </p:nvSpPr>
         <p:spPr>
           <a:xfrm>
-            <a:off x="10210800" y="6032500"/>
-            <a:ext cx="1270000" cy="254000"/>
+            <a:off x="10033000" y="5943600"/>
+            <a:ext cx="1549400" cy="342900"/>
           </a:xfrm>
           <a:prstGeom prst="rect">
             <a:avLst/>
@@ -4567,17 +4852,17 @@
           <a:p>
             <a:pPr algn="r">
               <a:lnSpc>
-                <a:spcPct val="100000"/>
+                <a:spcPct val="105000"/>
               </a:lnSpc>
             </a:pPr>
             <a:r>
-              <a:rPr sz="1400" b="0">
-                <a:solidFill>
-                  <a:srgbClr val="5F6A65"/>
-                </a:solidFill>
-                <a:latin typeface="Geist Mono"/>
+              <a:rPr sz="1600" b="1">
+                <a:solidFill>
+                  <a:srgbClr val="5B6B94"/>
+                </a:solidFill>
+                <a:latin typeface="Consolas"/>
               </a:rPr>
-              <a:t>02 / 07</a:t>
+              <a:t>02 / 08</a:t>
             </a:r>
           </a:p>
         </p:txBody>
@@ -4596,7 +4881,7 @@
     <p:bg>
       <p:bgPr>
         <a:solidFill>
-          <a:srgbClr val="F7F8F7"/>
+          <a:srgbClr val="EEF3FD"/>
         </a:solidFill>
         <a:effectLst/>
       </p:bgPr>
@@ -4616,8 +4901,8 @@
         </p:nvSpPr>
         <p:spPr>
           <a:xfrm>
-            <a:off x="711200" y="698500"/>
-            <a:ext cx="9906000" cy="889000"/>
+            <a:off x="660400" y="609600"/>
+            <a:ext cx="7620000" cy="406400"/>
           </a:xfrm>
           <a:prstGeom prst="rect">
             <a:avLst/>
@@ -4632,24 +4917,389 @@
           <a:p>
             <a:pPr algn="l">
               <a:lnSpc>
-                <a:spcPct val="100000"/>
+                <a:spcPct val="105000"/>
               </a:lnSpc>
             </a:pPr>
             <a:r>
-              <a:rPr sz="4800" b="1" spc="-120">
-                <a:solidFill>
-                  <a:srgbClr val="141A17"/>
-                </a:solidFill>
-                <a:latin typeface="Geist"/>
+              <a:rPr sz="2000" b="1" spc="80">
+                <a:solidFill>
+                  <a:srgbClr val="2150E8"/>
+                </a:solidFill>
+                <a:latin typeface="Consolas"/>
               </a:rPr>
-              <a:t>El flete se come la ganancia</a:t>
+              <a:t>02 · EL CUELLO DE BOTELLA</a:t>
+            </a:r>
+          </a:p>
+        </p:txBody>
+      </p:sp>
+      <p:sp>
+        <p:nvSpPr>
+          <p:cNvPr id="3" name="TextBox 2"/>
+          <p:cNvSpPr txBox="1"/>
+          <p:nvPr/>
+        </p:nvSpPr>
+        <p:spPr>
+          <a:xfrm>
+            <a:off x="660400" y="1143000"/>
+            <a:ext cx="10160000" cy="825500"/>
+          </a:xfrm>
+          <a:prstGeom prst="rect">
+            <a:avLst/>
+          </a:prstGeom>
+          <a:noFill/>
+        </p:spPr>
+        <p:txBody>
+          <a:bodyPr wrap="square" lIns="0" rIns="0" tIns="0" bIns="0" anchor="t">
+            <a:noAutofit/>
+          </a:bodyPr>
+          <a:lstStyle/>
+          <a:p>
+            <a:pPr algn="l">
+              <a:lnSpc>
+                <a:spcPct val="105000"/>
+              </a:lnSpc>
+            </a:pPr>
+            <a:r>
+              <a:rPr sz="4200" b="1" spc="-84">
+                <a:solidFill>
+                  <a:srgbClr val="0A1433"/>
+                </a:solidFill>
+                <a:latin typeface="Segoe UI"/>
+              </a:rPr>
+              <a:t>Un camión lleno de aire</a:t>
+            </a:r>
+          </a:p>
+        </p:txBody>
+      </p:sp>
+      <p:sp>
+        <p:nvSpPr>
+          <p:cNvPr id="4" name="Rectangle 3"/>
+          <p:cNvSpPr/>
+          <p:nvPr/>
+        </p:nvSpPr>
+        <p:spPr>
+          <a:xfrm>
+            <a:off x="660400" y="2159000"/>
+            <a:ext cx="5207000" cy="3429000"/>
+          </a:xfrm>
+          <a:prstGeom prst="rect">
+            <a:avLst/>
+          </a:prstGeom>
+          <a:solidFill>
+            <a:srgbClr val="FFFFFF"/>
+          </a:solidFill>
+          <a:ln w="12700">
+            <a:solidFill>
+              <a:srgbClr val="D3DEF3"/>
+            </a:solidFill>
+          </a:ln>
+          <a:effectLst/>
+        </p:spPr>
+        <p:style>
+          <a:lnRef idx="1">
+            <a:schemeClr val="accent1"/>
+          </a:lnRef>
+          <a:fillRef idx="3">
+            <a:schemeClr val="accent1"/>
+          </a:fillRef>
+          <a:effectRef idx="2">
+            <a:schemeClr val="accent1"/>
+          </a:effectRef>
+          <a:fontRef idx="minor">
+            <a:schemeClr val="lt1"/>
+          </a:fontRef>
+        </p:style>
+        <p:txBody>
+          <a:bodyPr rtlCol="0" anchor="ctr"/>
+          <a:lstStyle/>
+          <a:p>
+            <a:pPr algn="ctr"/>
+          </a:p>
+        </p:txBody>
+      </p:sp>
+      <p:sp>
+        <p:nvSpPr>
+          <p:cNvPr id="5" name="TextBox 4"/>
+          <p:cNvSpPr txBox="1"/>
+          <p:nvPr/>
+        </p:nvSpPr>
+        <p:spPr>
+          <a:xfrm>
+            <a:off x="965200" y="2387600"/>
+            <a:ext cx="4597400" cy="406400"/>
+          </a:xfrm>
+          <a:prstGeom prst="rect">
+            <a:avLst/>
+          </a:prstGeom>
+          <a:noFill/>
+        </p:spPr>
+        <p:txBody>
+          <a:bodyPr wrap="square" lIns="0" rIns="0" tIns="0" bIns="0" anchor="t">
+            <a:noAutofit/>
+          </a:bodyPr>
+          <a:lstStyle/>
+          <a:p>
+            <a:pPr algn="l">
+              <a:lnSpc>
+                <a:spcPct val="105000"/>
+              </a:lnSpc>
+            </a:pPr>
+            <a:r>
+              <a:rPr sz="2000" b="1" spc="80">
+                <a:solidFill>
+                  <a:srgbClr val="B5402A"/>
+                </a:solidFill>
+                <a:latin typeface="Consolas"/>
+              </a:rPr>
+              <a:t>CASCARILLA SUELTA · 108 KG/M³</a:t>
+            </a:r>
+          </a:p>
+        </p:txBody>
+      </p:sp>
+      <p:sp>
+        <p:nvSpPr>
+          <p:cNvPr id="6" name="TextBox 5"/>
+          <p:cNvSpPr txBox="1"/>
+          <p:nvPr/>
+        </p:nvSpPr>
+        <p:spPr>
+          <a:xfrm>
+            <a:off x="965200" y="2921000"/>
+            <a:ext cx="4597400" cy="952500"/>
+          </a:xfrm>
+          <a:prstGeom prst="rect">
+            <a:avLst/>
+          </a:prstGeom>
+          <a:noFill/>
+        </p:spPr>
+        <p:txBody>
+          <a:bodyPr wrap="square" lIns="0" rIns="0" tIns="0" bIns="0" anchor="t">
+            <a:noAutofit/>
+          </a:bodyPr>
+          <a:lstStyle/>
+          <a:p>
+            <a:pPr algn="l">
+              <a:lnSpc>
+                <a:spcPct val="105000"/>
+              </a:lnSpc>
+            </a:pPr>
+            <a:r>
+              <a:rPr sz="4600" b="1">
+                <a:solidFill>
+                  <a:srgbClr val="B5402A"/>
+                </a:solidFill>
+                <a:latin typeface="Consolas"/>
+              </a:rPr>
+              <a:t>25 km máx</a:t>
+            </a:r>
+          </a:p>
+        </p:txBody>
+      </p:sp>
+      <p:sp>
+        <p:nvSpPr>
+          <p:cNvPr id="7" name="TextBox 6"/>
+          <p:cNvSpPr txBox="1"/>
+          <p:nvPr/>
+        </p:nvSpPr>
+        <p:spPr>
+          <a:xfrm>
+            <a:off x="965200" y="4013200"/>
+            <a:ext cx="4597400" cy="1397000"/>
+          </a:xfrm>
+          <a:prstGeom prst="rect">
+            <a:avLst/>
+          </a:prstGeom>
+          <a:noFill/>
+        </p:spPr>
+        <p:txBody>
+          <a:bodyPr wrap="square" lIns="0" rIns="0" tIns="0" bIns="0" anchor="t">
+            <a:noAutofit/>
+          </a:bodyPr>
+          <a:lstStyle/>
+          <a:p>
+            <a:pPr algn="l">
+              <a:lnSpc>
+                <a:spcPct val="112000"/>
+              </a:lnSpc>
+            </a:pPr>
+            <a:r>
+              <a:rPr sz="2100" b="0">
+                <a:solidFill>
+                  <a:srgbClr val="3D4D7A"/>
+                </a:solidFill>
+                <a:latin typeface="Segoe UI"/>
+              </a:rPr>
+              <a:t>70 % del camión viaja con aire: solo entran 9,7 t de las 30 t posibles.</a:t>
+            </a:r>
+          </a:p>
+        </p:txBody>
+      </p:sp>
+      <p:sp>
+        <p:nvSpPr>
+          <p:cNvPr id="8" name="Rectangle 7"/>
+          <p:cNvSpPr/>
+          <p:nvPr/>
+        </p:nvSpPr>
+        <p:spPr>
+          <a:xfrm>
+            <a:off x="6299200" y="2159000"/>
+            <a:ext cx="5207000" cy="3429000"/>
+          </a:xfrm>
+          <a:prstGeom prst="rect">
+            <a:avLst/>
+          </a:prstGeom>
+          <a:solidFill>
+            <a:srgbClr val="FFFFFF"/>
+          </a:solidFill>
+          <a:ln w="12700">
+            <a:solidFill>
+              <a:srgbClr val="D3DEF3"/>
+            </a:solidFill>
+          </a:ln>
+          <a:effectLst/>
+        </p:spPr>
+        <p:style>
+          <a:lnRef idx="1">
+            <a:schemeClr val="accent1"/>
+          </a:lnRef>
+          <a:fillRef idx="3">
+            <a:schemeClr val="accent1"/>
+          </a:fillRef>
+          <a:effectRef idx="2">
+            <a:schemeClr val="accent1"/>
+          </a:effectRef>
+          <a:fontRef idx="minor">
+            <a:schemeClr val="lt1"/>
+          </a:fontRef>
+        </p:style>
+        <p:txBody>
+          <a:bodyPr rtlCol="0" anchor="ctr"/>
+          <a:lstStyle/>
+          <a:p>
+            <a:pPr algn="ctr"/>
+          </a:p>
+        </p:txBody>
+      </p:sp>
+      <p:sp>
+        <p:nvSpPr>
+          <p:cNvPr id="9" name="TextBox 8"/>
+          <p:cNvSpPr txBox="1"/>
+          <p:nvPr/>
+        </p:nvSpPr>
+        <p:spPr>
+          <a:xfrm>
+            <a:off x="6604000" y="2387600"/>
+            <a:ext cx="4597400" cy="406400"/>
+          </a:xfrm>
+          <a:prstGeom prst="rect">
+            <a:avLst/>
+          </a:prstGeom>
+          <a:noFill/>
+        </p:spPr>
+        <p:txBody>
+          <a:bodyPr wrap="square" lIns="0" rIns="0" tIns="0" bIns="0" anchor="t">
+            <a:noAutofit/>
+          </a:bodyPr>
+          <a:lstStyle/>
+          <a:p>
+            <a:pPr algn="l">
+              <a:lnSpc>
+                <a:spcPct val="105000"/>
+              </a:lnSpc>
+            </a:pPr>
+            <a:r>
+              <a:rPr sz="2000" b="1" spc="80">
+                <a:solidFill>
+                  <a:srgbClr val="17784A"/>
+                </a:solidFill>
+                <a:latin typeface="Consolas"/>
+              </a:rPr>
+              <a:t>EN PELLET · 650 KG/M³</a:t>
+            </a:r>
+          </a:p>
+        </p:txBody>
+      </p:sp>
+      <p:sp>
+        <p:nvSpPr>
+          <p:cNvPr id="10" name="TextBox 9"/>
+          <p:cNvSpPr txBox="1"/>
+          <p:nvPr/>
+        </p:nvSpPr>
+        <p:spPr>
+          <a:xfrm>
+            <a:off x="6604000" y="2921000"/>
+            <a:ext cx="4597400" cy="952500"/>
+          </a:xfrm>
+          <a:prstGeom prst="rect">
+            <a:avLst/>
+          </a:prstGeom>
+          <a:noFill/>
+        </p:spPr>
+        <p:txBody>
+          <a:bodyPr wrap="square" lIns="0" rIns="0" tIns="0" bIns="0" anchor="t">
+            <a:noAutofit/>
+          </a:bodyPr>
+          <a:lstStyle/>
+          <a:p>
+            <a:pPr algn="l">
+              <a:lnSpc>
+                <a:spcPct val="105000"/>
+              </a:lnSpc>
+            </a:pPr>
+            <a:r>
+              <a:rPr sz="4600" b="1">
+                <a:solidFill>
+                  <a:srgbClr val="17784A"/>
+                </a:solidFill>
+                <a:latin typeface="Consolas"/>
+              </a:rPr>
+              <a:t>310 km (12x)</a:t>
+            </a:r>
+          </a:p>
+        </p:txBody>
+      </p:sp>
+      <p:sp>
+        <p:nvSpPr>
+          <p:cNvPr id="11" name="TextBox 10"/>
+          <p:cNvSpPr txBox="1"/>
+          <p:nvPr/>
+        </p:nvSpPr>
+        <p:spPr>
+          <a:xfrm>
+            <a:off x="6604000" y="4013200"/>
+            <a:ext cx="4597400" cy="1397000"/>
+          </a:xfrm>
+          <a:prstGeom prst="rect">
+            <a:avLst/>
+          </a:prstGeom>
+          <a:noFill/>
+        </p:spPr>
+        <p:txBody>
+          <a:bodyPr wrap="square" lIns="0" rIns="0" tIns="0" bIns="0" anchor="t">
+            <a:noAutofit/>
+          </a:bodyPr>
+          <a:lstStyle/>
+          <a:p>
+            <a:pPr algn="l">
+              <a:lnSpc>
+                <a:spcPct val="112000"/>
+              </a:lnSpc>
+            </a:pPr>
+            <a:r>
+              <a:rPr sz="2100" b="0">
+                <a:solidFill>
+                  <a:srgbClr val="3D4D7A"/>
+                </a:solidFill>
+                <a:latin typeface="Segoe UI"/>
+              </a:rPr>
+              <a:t>Carga las 30 t completas y multiplica 12 veces el radio rentable.</a:t>
             </a:r>
           </a:p>
         </p:txBody>
       </p:sp>
       <p:pic>
         <p:nvPicPr>
-          <p:cNvPr id="3" name="Picture 2" descr="truck.png"/>
+          <p:cNvPr id="12" name="Picture 11" descr="icon.png"/>
           <p:cNvPicPr>
             <a:picLocks noChangeAspect="1"/>
           </p:cNvPicPr>
@@ -4664,8 +5314,8 @@
         </p:blipFill>
         <p:spPr>
           <a:xfrm>
-            <a:off x="711200" y="2540000"/>
-            <a:ext cx="2032000" cy="2032000"/>
+            <a:off x="11176000" y="558800"/>
+            <a:ext cx="406400" cy="406400"/>
           </a:xfrm>
           <a:prstGeom prst="rect">
             <a:avLst/>
@@ -4674,14 +5324,14 @@
       </p:pic>
       <p:sp>
         <p:nvSpPr>
-          <p:cNvPr id="4" name="TextBox 3"/>
+          <p:cNvPr id="13" name="TextBox 12"/>
           <p:cNvSpPr txBox="1"/>
           <p:nvPr/>
         </p:nvSpPr>
         <p:spPr>
           <a:xfrm>
-            <a:off x="3175000" y="2095500"/>
-            <a:ext cx="8255000" cy="2387600"/>
+            <a:off x="10033000" y="5943600"/>
+            <a:ext cx="1549400" cy="342900"/>
           </a:xfrm>
           <a:prstGeom prst="rect">
             <a:avLst/>
@@ -4694,131 +5344,19 @@
           </a:bodyPr>
           <a:lstStyle/>
           <a:p>
-            <a:pPr algn="l">
+            <a:pPr algn="r">
               <a:lnSpc>
-                <a:spcPct val="100000"/>
+                <a:spcPct val="105000"/>
               </a:lnSpc>
             </a:pPr>
             <a:r>
-              <a:rPr sz="12000" b="1">
-                <a:solidFill>
-                  <a:srgbClr val="141A17"/>
-                </a:solidFill>
-                <a:latin typeface="Geist Mono"/>
+              <a:rPr sz="1600" b="1">
+                <a:solidFill>
+                  <a:srgbClr val="5B6B94"/>
+                </a:solidFill>
+                <a:latin typeface="Consolas"/>
               </a:rPr>
-              <a:t>108</a:t>
-            </a:r>
-            <a:r>
-              <a:rPr sz="4800" b="1">
-                <a:solidFill>
-                  <a:srgbClr val="141A17"/>
-                </a:solidFill>
-                <a:latin typeface="Geist Mono"/>
-              </a:rPr>
-              <a:t> kg/m³</a:t>
-            </a:r>
-          </a:p>
-        </p:txBody>
-      </p:sp>
-      <p:sp>
-        <p:nvSpPr>
-          <p:cNvPr id="5" name="TextBox 4"/>
-          <p:cNvSpPr txBox="1"/>
-          <p:nvPr/>
-        </p:nvSpPr>
-        <p:spPr>
-          <a:xfrm>
-            <a:off x="3175000" y="4546600"/>
-            <a:ext cx="8255000" cy="952500"/>
-          </a:xfrm>
-          <a:prstGeom prst="rect">
-            <a:avLst/>
-          </a:prstGeom>
-          <a:noFill/>
-        </p:spPr>
-        <p:txBody>
-          <a:bodyPr wrap="square" lIns="0" rIns="0" tIns="0" bIns="0" anchor="t">
-            <a:noAutofit/>
-          </a:bodyPr>
-          <a:lstStyle/>
-          <a:p>
-            <a:pPr algn="l">
-              <a:lnSpc>
-                <a:spcPct val="115000"/>
-              </a:lnSpc>
-            </a:pPr>
-            <a:r>
-              <a:rPr sz="2400" b="0">
-                <a:solidFill>
-                  <a:srgbClr val="55605B"/>
-                </a:solidFill>
-                <a:latin typeface="Geist"/>
-              </a:rPr>
-              <a:t>Cascarilla suelta: el camión se llena de aire</a:t>
-            </a:r>
-          </a:p>
-        </p:txBody>
-      </p:sp>
-      <p:pic>
-        <p:nvPicPr>
-          <p:cNvPr id="6" name="Picture 5" descr="icon.png"/>
-          <p:cNvPicPr>
-            <a:picLocks noChangeAspect="1"/>
-          </p:cNvPicPr>
-          <p:nvPr/>
-        </p:nvPicPr>
-        <p:blipFill>
-          <a:blip r:embed="rId3"/>
-          <a:srcRect/>
-          <a:stretch>
-            <a:fillRect/>
-          </a:stretch>
-        </p:blipFill>
-        <p:spPr>
-          <a:xfrm>
-            <a:off x="11074400" y="609600"/>
-            <a:ext cx="406400" cy="406400"/>
-          </a:xfrm>
-          <a:prstGeom prst="rect">
-            <a:avLst/>
-          </a:prstGeom>
-        </p:spPr>
-      </p:pic>
-      <p:sp>
-        <p:nvSpPr>
-          <p:cNvPr id="7" name="TextBox 6"/>
-          <p:cNvSpPr txBox="1"/>
-          <p:nvPr/>
-        </p:nvSpPr>
-        <p:spPr>
-          <a:xfrm>
-            <a:off x="10210800" y="6032500"/>
-            <a:ext cx="1270000" cy="254000"/>
-          </a:xfrm>
-          <a:prstGeom prst="rect">
-            <a:avLst/>
-          </a:prstGeom>
-          <a:noFill/>
-        </p:spPr>
-        <p:txBody>
-          <a:bodyPr wrap="square" lIns="0" rIns="0" tIns="0" bIns="0" anchor="t">
-            <a:noAutofit/>
-          </a:bodyPr>
-          <a:lstStyle/>
-          <a:p>
-            <a:pPr algn="r">
-              <a:lnSpc>
-                <a:spcPct val="100000"/>
-              </a:lnSpc>
-            </a:pPr>
-            <a:r>
-              <a:rPr sz="1400" b="0">
-                <a:solidFill>
-                  <a:srgbClr val="5F6A65"/>
-                </a:solidFill>
-                <a:latin typeface="Geist Mono"/>
-              </a:rPr>
-              <a:t>03 / 07</a:t>
+              <a:t>03 / 08</a:t>
             </a:r>
           </a:p>
         </p:txBody>
@@ -4837,7 +5375,7 @@
     <p:bg>
       <p:bgPr>
         <a:solidFill>
-          <a:srgbClr val="F7F8F7"/>
+          <a:srgbClr val="EEF3FD"/>
         </a:solidFill>
         <a:effectLst/>
       </p:bgPr>
@@ -4857,8 +5395,47 @@
         </p:nvSpPr>
         <p:spPr>
           <a:xfrm>
-            <a:off x="711200" y="660400"/>
-            <a:ext cx="4826000" cy="1879600"/>
+            <a:off x="660400" y="609600"/>
+            <a:ext cx="4445000" cy="406400"/>
+          </a:xfrm>
+          <a:prstGeom prst="rect">
+            <a:avLst/>
+          </a:prstGeom>
+          <a:noFill/>
+        </p:spPr>
+        <p:txBody>
+          <a:bodyPr wrap="square" lIns="0" rIns="0" tIns="0" bIns="0" anchor="t">
+            <a:noAutofit/>
+          </a:bodyPr>
+          <a:lstStyle/>
+          <a:p>
+            <a:pPr algn="l">
+              <a:lnSpc>
+                <a:spcPct val="105000"/>
+              </a:lnSpc>
+            </a:pPr>
+            <a:r>
+              <a:rPr sz="2000" b="1" spc="80">
+                <a:solidFill>
+                  <a:srgbClr val="2150E8"/>
+                </a:solidFill>
+                <a:latin typeface="Consolas"/>
+              </a:rPr>
+              <a:t>03 · LA SOLUCIÓN</a:t>
+            </a:r>
+          </a:p>
+        </p:txBody>
+      </p:sp>
+      <p:sp>
+        <p:nvSpPr>
+          <p:cNvPr id="3" name="TextBox 2"/>
+          <p:cNvSpPr txBox="1"/>
+          <p:nvPr/>
+        </p:nvSpPr>
+        <p:spPr>
+          <a:xfrm>
+            <a:off x="660400" y="1143000"/>
+            <a:ext cx="4572000" cy="1524000"/>
           </a:xfrm>
           <a:prstGeom prst="rect">
             <a:avLst/>
@@ -4877,38 +5454,15 @@
               </a:lnSpc>
             </a:pPr>
             <a:r>
-              <a:rPr sz="5200" b="1" spc="-130">
-                <a:solidFill>
-                  <a:srgbClr val="141A17"/>
-                </a:solidFill>
-                <a:latin typeface="Geist"/>
+              <a:rPr sz="4200" b="1" spc="-84">
+                <a:solidFill>
+                  <a:srgbClr val="0A1433"/>
+                </a:solidFill>
+                <a:latin typeface="Segoe UI"/>
               </a:rPr>
-              <a:t>¿Cierra el negocio?</a:t>
-            </a:r>
-          </a:p>
-        </p:txBody>
-      </p:sp>
-      <p:sp>
-        <p:nvSpPr>
-          <p:cNvPr id="3" name="TextBox 2"/>
-          <p:cNvSpPr txBox="1"/>
-          <p:nvPr/>
-        </p:nvSpPr>
-        <p:spPr>
-          <a:xfrm>
-            <a:off x="711200" y="2768600"/>
-            <a:ext cx="508000" cy="381000"/>
-          </a:xfrm>
-          <a:prstGeom prst="rect">
-            <a:avLst/>
-          </a:prstGeom>
-          <a:noFill/>
-        </p:spPr>
-        <p:txBody>
-          <a:bodyPr wrap="square" lIns="0" rIns="0" tIns="0" bIns="0" anchor="t">
-            <a:noAutofit/>
-          </a:bodyPr>
-          <a:lstStyle/>
+              <a:t>¿Cierra el</a:t>
+            </a:r>
+          </a:p>
           <a:p>
             <a:pPr algn="l">
               <a:lnSpc>
@@ -4916,13 +5470,13 @@
               </a:lnSpc>
             </a:pPr>
             <a:r>
-              <a:rPr sz="2000" b="0">
-                <a:solidFill>
-                  <a:srgbClr val="3A7254"/>
-                </a:solidFill>
-                <a:latin typeface="Geist Mono"/>
+              <a:rPr sz="4200" b="1" spc="-84">
+                <a:solidFill>
+                  <a:srgbClr val="2150E8"/>
+                </a:solidFill>
+                <a:latin typeface="Segoe UI"/>
               </a:rPr>
-              <a:t>01</a:t>
+              <a:t>negocio?</a:t>
             </a:r>
           </a:p>
         </p:txBody>
@@ -4935,8 +5489,8 @@
         </p:nvSpPr>
         <p:spPr>
           <a:xfrm>
-            <a:off x="1270000" y="2667000"/>
-            <a:ext cx="4318000" cy="889000"/>
+            <a:off x="660400" y="2857500"/>
+            <a:ext cx="4572000" cy="825500"/>
           </a:xfrm>
           <a:prstGeom prst="rect">
             <a:avLst/>
@@ -4951,17 +5505,26 @@
           <a:p>
             <a:pPr algn="l">
               <a:lnSpc>
-                <a:spcPct val="110000"/>
+                <a:spcPct val="105000"/>
               </a:lnSpc>
             </a:pPr>
             <a:r>
-              <a:rPr sz="2600" b="1">
-                <a:solidFill>
-                  <a:srgbClr val="141A17"/>
-                </a:solidFill>
-                <a:latin typeface="Geist"/>
+              <a:rPr sz="2100" b="1">
+                <a:solidFill>
+                  <a:srgbClr val="2150E8"/>
+                </a:solidFill>
+                <a:latin typeface="Consolas"/>
               </a:rPr>
-              <a:t>Mapa de residuos</a:t>
+              <a:t>01  </a:t>
+            </a:r>
+            <a:r>
+              <a:rPr sz="2100" b="1">
+                <a:solidFill>
+                  <a:srgbClr val="0A1433"/>
+                </a:solidFill>
+                <a:latin typeface="Segoe UI"/>
+              </a:rPr>
+              <a:t>13 plantas y 10 industrias reales</a:t>
             </a:r>
           </a:p>
         </p:txBody>
@@ -4974,8 +5537,8 @@
         </p:nvSpPr>
         <p:spPr>
           <a:xfrm>
-            <a:off x="711200" y="3721100"/>
-            <a:ext cx="508000" cy="381000"/>
+            <a:off x="660400" y="3810000"/>
+            <a:ext cx="4572000" cy="825500"/>
           </a:xfrm>
           <a:prstGeom prst="rect">
             <a:avLst/>
@@ -4990,17 +5553,26 @@
           <a:p>
             <a:pPr algn="l">
               <a:lnSpc>
-                <a:spcPct val="100000"/>
+                <a:spcPct val="105000"/>
               </a:lnSpc>
             </a:pPr>
             <a:r>
-              <a:rPr sz="2000" b="0">
-                <a:solidFill>
-                  <a:srgbClr val="3A7254"/>
-                </a:solidFill>
-                <a:latin typeface="Geist Mono"/>
+              <a:rPr sz="2100" b="1">
+                <a:solidFill>
+                  <a:srgbClr val="2150E8"/>
+                </a:solidFill>
+                <a:latin typeface="Consolas"/>
               </a:rPr>
-              <a:t>02</a:t>
+              <a:t>02  </a:t>
+            </a:r>
+            <a:r>
+              <a:rPr sz="2100" b="1">
+                <a:solidFill>
+                  <a:srgbClr val="0A1433"/>
+                </a:solidFill>
+                <a:latin typeface="Segoe UI"/>
+              </a:rPr>
+              <a:t>Simula suelto o pellet en 1 clic</a:t>
             </a:r>
           </a:p>
         </p:txBody>
@@ -5013,8 +5585,8 @@
         </p:nvSpPr>
         <p:spPr>
           <a:xfrm>
-            <a:off x="1270000" y="3619500"/>
-            <a:ext cx="4318000" cy="889000"/>
+            <a:off x="660400" y="4762500"/>
+            <a:ext cx="4572000" cy="825500"/>
           </a:xfrm>
           <a:prstGeom prst="rect">
             <a:avLst/>
@@ -5029,102 +5601,33 @@
           <a:p>
             <a:pPr algn="l">
               <a:lnSpc>
-                <a:spcPct val="110000"/>
+                <a:spcPct val="105000"/>
               </a:lnSpc>
             </a:pPr>
             <a:r>
-              <a:rPr sz="2600" b="1">
-                <a:solidFill>
-                  <a:srgbClr val="141A17"/>
-                </a:solidFill>
-                <a:latin typeface="Geist"/>
+              <a:rPr sz="2100" b="1">
+                <a:solidFill>
+                  <a:srgbClr val="2150E8"/>
+                </a:solidFill>
+                <a:latin typeface="Consolas"/>
               </a:rPr>
-              <a:t>Margen después del flete</a:t>
-            </a:r>
-          </a:p>
-        </p:txBody>
-      </p:sp>
-      <p:sp>
-        <p:nvSpPr>
-          <p:cNvPr id="7" name="TextBox 6"/>
-          <p:cNvSpPr txBox="1"/>
-          <p:nvPr/>
-        </p:nvSpPr>
-        <p:spPr>
-          <a:xfrm>
-            <a:off x="711200" y="4673600"/>
-            <a:ext cx="508000" cy="381000"/>
-          </a:xfrm>
-          <a:prstGeom prst="rect">
-            <a:avLst/>
-          </a:prstGeom>
-          <a:noFill/>
-        </p:spPr>
-        <p:txBody>
-          <a:bodyPr wrap="square" lIns="0" rIns="0" tIns="0" bIns="0" anchor="t">
-            <a:noAutofit/>
-          </a:bodyPr>
-          <a:lstStyle/>
-          <a:p>
-            <a:pPr algn="l">
-              <a:lnSpc>
-                <a:spcPct val="100000"/>
-              </a:lnSpc>
-            </a:pPr>
-            <a:r>
-              <a:rPr sz="2000" b="0">
-                <a:solidFill>
-                  <a:srgbClr val="3A7254"/>
-                </a:solidFill>
-                <a:latin typeface="Geist Mono"/>
+              <a:t>03  </a:t>
+            </a:r>
+            <a:r>
+              <a:rPr sz="2100" b="1">
+                <a:solidFill>
+                  <a:srgbClr val="0A1433"/>
+                </a:solidFill>
+                <a:latin typeface="Segoe UI"/>
               </a:rPr>
-              <a:t>03</a:t>
-            </a:r>
-          </a:p>
-        </p:txBody>
-      </p:sp>
-      <p:sp>
-        <p:nvSpPr>
-          <p:cNvPr id="8" name="TextBox 7"/>
-          <p:cNvSpPr txBox="1"/>
-          <p:nvPr/>
-        </p:nvSpPr>
-        <p:spPr>
-          <a:xfrm>
-            <a:off x="1270000" y="4572000"/>
-            <a:ext cx="4318000" cy="889000"/>
-          </a:xfrm>
-          <a:prstGeom prst="rect">
-            <a:avLst/>
-          </a:prstGeom>
-          <a:noFill/>
-        </p:spPr>
-        <p:txBody>
-          <a:bodyPr wrap="square" lIns="0" rIns="0" tIns="0" bIns="0" anchor="t">
-            <a:noAutofit/>
-          </a:bodyPr>
-          <a:lstStyle/>
-          <a:p>
-            <a:pPr algn="l">
-              <a:lnSpc>
-                <a:spcPct val="110000"/>
-              </a:lnSpc>
-            </a:pPr>
-            <a:r>
-              <a:rPr sz="2600" b="1">
-                <a:solidFill>
-                  <a:srgbClr val="141A17"/>
-                </a:solidFill>
-                <a:latin typeface="Geist"/>
-              </a:rPr>
-              <a:t>Semáforo: cierra o no</a:t>
+              <a:t>Semáforo de margen neto real</a:t>
             </a:r>
           </a:p>
         </p:txBody>
       </p:sp>
       <p:pic>
         <p:nvPicPr>
-          <p:cNvPr id="9" name="Picture 8" descr="03-pellet.jpg"/>
+          <p:cNvPr id="7" name="Picture 6" descr="01-inicio.png"/>
           <p:cNvPicPr>
             <a:picLocks noChangeAspect="1"/>
           </p:cNvPicPr>
@@ -5132,29 +5635,29 @@
         </p:nvPicPr>
         <p:blipFill>
           <a:blip r:embed="rId2"/>
-          <a:srcRect l="3969" r="2433" t="0" b="0"/>
+          <a:srcRect/>
           <a:stretch>
             <a:fillRect/>
           </a:stretch>
         </p:blipFill>
         <p:spPr>
           <a:xfrm>
-            <a:off x="5842000" y="1270000"/>
-            <a:ext cx="5638800" cy="4635500"/>
-          </a:xfrm>
-          <a:prstGeom prst="rect">
-            <a:avLst/>
-          </a:prstGeom>
-          <a:ln w="9525">
+            <a:off x="5435600" y="1651000"/>
+            <a:ext cx="6096000" cy="3429000"/>
+          </a:xfrm>
+          <a:prstGeom prst="rect">
+            <a:avLst/>
+          </a:prstGeom>
+          <a:ln w="19050">
             <a:solidFill>
-              <a:srgbClr val="DFE4E1"/>
+              <a:srgbClr val="2150E8"/>
             </a:solidFill>
           </a:ln>
         </p:spPr>
       </p:pic>
       <p:pic>
         <p:nvPicPr>
-          <p:cNvPr id="10" name="Picture 9" descr="icon.png"/>
+          <p:cNvPr id="8" name="Picture 7" descr="icon.png"/>
           <p:cNvPicPr>
             <a:picLocks noChangeAspect="1"/>
           </p:cNvPicPr>
@@ -5169,7 +5672,7 @@
         </p:blipFill>
         <p:spPr>
           <a:xfrm>
-            <a:off x="11074400" y="609600"/>
+            <a:off x="11176000" y="558800"/>
             <a:ext cx="406400" cy="406400"/>
           </a:xfrm>
           <a:prstGeom prst="rect">
@@ -5179,14 +5682,14 @@
       </p:pic>
       <p:sp>
         <p:nvSpPr>
-          <p:cNvPr id="11" name="TextBox 10"/>
+          <p:cNvPr id="9" name="TextBox 8"/>
           <p:cNvSpPr txBox="1"/>
           <p:nvPr/>
         </p:nvSpPr>
         <p:spPr>
           <a:xfrm>
-            <a:off x="10210800" y="6032500"/>
-            <a:ext cx="1270000" cy="254000"/>
+            <a:off x="10033000" y="5943600"/>
+            <a:ext cx="1549400" cy="342900"/>
           </a:xfrm>
           <a:prstGeom prst="rect">
             <a:avLst/>
@@ -5201,17 +5704,17 @@
           <a:p>
             <a:pPr algn="r">
               <a:lnSpc>
-                <a:spcPct val="100000"/>
+                <a:spcPct val="105000"/>
               </a:lnSpc>
             </a:pPr>
             <a:r>
-              <a:rPr sz="1400" b="0">
-                <a:solidFill>
-                  <a:srgbClr val="5F6A65"/>
-                </a:solidFill>
-                <a:latin typeface="Geist Mono"/>
+              <a:rPr sz="1600" b="1">
+                <a:solidFill>
+                  <a:srgbClr val="5B6B94"/>
+                </a:solidFill>
+                <a:latin typeface="Consolas"/>
               </a:rPr>
-              <a:t>04 / 07</a:t>
+              <a:t>04 / 08</a:t>
             </a:r>
           </a:p>
         </p:txBody>
@@ -5230,7 +5733,7 @@
     <p:bg>
       <p:bgPr>
         <a:solidFill>
-          <a:srgbClr val="F7F8F7"/>
+          <a:srgbClr val="EEF3FD"/>
         </a:solidFill>
         <a:effectLst/>
       </p:bgPr>
@@ -5250,8 +5753,8 @@
         </p:nvSpPr>
         <p:spPr>
           <a:xfrm>
-            <a:off x="711200" y="698500"/>
-            <a:ext cx="9525000" cy="889000"/>
+            <a:off x="660400" y="609600"/>
+            <a:ext cx="9525000" cy="406400"/>
           </a:xfrm>
           <a:prstGeom prst="rect">
             <a:avLst/>
@@ -5266,24 +5769,63 @@
           <a:p>
             <a:pPr algn="l">
               <a:lnSpc>
-                <a:spcPct val="100000"/>
+                <a:spcPct val="105000"/>
               </a:lnSpc>
             </a:pPr>
             <a:r>
-              <a:rPr sz="4800" b="1" spc="-120">
-                <a:solidFill>
-                  <a:srgbClr val="141A17"/>
-                </a:solidFill>
-                <a:latin typeface="Geist"/>
+              <a:rPr sz="2000" b="1" spc="80">
+                <a:solidFill>
+                  <a:srgbClr val="2150E8"/>
+                </a:solidFill>
+                <a:latin typeface="Consolas"/>
               </a:rPr>
-              <a:t>Pelletizar cambia el mapa</a:t>
+              <a:t>04 · DEMO REAL · MOLINOS ALA A FRIGORÍFICO DUHALDE (88 KM)</a:t>
+            </a:r>
+          </a:p>
+        </p:txBody>
+      </p:sp>
+      <p:sp>
+        <p:nvSpPr>
+          <p:cNvPr id="3" name="TextBox 2"/>
+          <p:cNvSpPr txBox="1"/>
+          <p:nvPr/>
+        </p:nvSpPr>
+        <p:spPr>
+          <a:xfrm>
+            <a:off x="660400" y="1117600"/>
+            <a:ext cx="10160000" cy="730250"/>
+          </a:xfrm>
+          <a:prstGeom prst="rect">
+            <a:avLst/>
+          </a:prstGeom>
+          <a:noFill/>
+        </p:spPr>
+        <p:txBody>
+          <a:bodyPr wrap="square" lIns="0" rIns="0" tIns="0" bIns="0" anchor="t">
+            <a:noAutofit/>
+          </a:bodyPr>
+          <a:lstStyle/>
+          <a:p>
+            <a:pPr algn="l">
+              <a:lnSpc>
+                <a:spcPct val="105000"/>
+              </a:lnSpc>
+            </a:pPr>
+            <a:r>
+              <a:rPr sz="3800" b="1" spc="-76">
+                <a:solidFill>
+                  <a:srgbClr val="0A1433"/>
+                </a:solidFill>
+                <a:latin typeface="Segoe UI"/>
+              </a:rPr>
+              <a:t>De pérdida a ganancia en un clic</a:t>
             </a:r>
           </a:p>
         </p:txBody>
       </p:sp>
       <p:pic>
         <p:nvPicPr>
-          <p:cNvPr id="3" name="Picture 2" descr="02-suelto.jpg"/>
+          <p:cNvPr id="4" name="Picture 3" descr="02-suelto.png"/>
           <p:cNvPicPr>
             <a:picLocks noChangeAspect="1"/>
           </p:cNvPicPr>
@@ -5291,29 +5833,107 @@
         </p:nvPicPr>
         <p:blipFill>
           <a:blip r:embed="rId2"/>
-          <a:srcRect t="15585" b="28943"/>
+          <a:srcRect/>
           <a:stretch>
             <a:fillRect/>
           </a:stretch>
         </p:blipFill>
         <p:spPr>
           <a:xfrm>
-            <a:off x="711200" y="1651000"/>
-            <a:ext cx="5207000" cy="2222500"/>
-          </a:xfrm>
-          <a:prstGeom prst="rect">
-            <a:avLst/>
-          </a:prstGeom>
-          <a:ln w="9525">
+            <a:off x="660400" y="1968500"/>
+            <a:ext cx="5080000" cy="2857500"/>
+          </a:xfrm>
+          <a:prstGeom prst="rect">
+            <a:avLst/>
+          </a:prstGeom>
+          <a:ln w="19050">
             <a:solidFill>
-              <a:srgbClr val="DFE4E1"/>
+              <a:srgbClr val="2150E8"/>
             </a:solidFill>
           </a:ln>
         </p:spPr>
       </p:pic>
+      <p:sp>
+        <p:nvSpPr>
+          <p:cNvPr id="5" name="TextBox 4"/>
+          <p:cNvSpPr txBox="1"/>
+          <p:nvPr/>
+        </p:nvSpPr>
+        <p:spPr>
+          <a:xfrm>
+            <a:off x="660400" y="4953000"/>
+            <a:ext cx="5080000" cy="381000"/>
+          </a:xfrm>
+          <a:prstGeom prst="rect">
+            <a:avLst/>
+          </a:prstGeom>
+          <a:noFill/>
+        </p:spPr>
+        <p:txBody>
+          <a:bodyPr wrap="square" lIns="0" rIns="0" tIns="0" bIns="0" anchor="t">
+            <a:noAutofit/>
+          </a:bodyPr>
+          <a:lstStyle/>
+          <a:p>
+            <a:pPr algn="l">
+              <a:lnSpc>
+                <a:spcPct val="105000"/>
+              </a:lnSpc>
+            </a:pPr>
+            <a:r>
+              <a:rPr sz="2000" b="1" spc="80">
+                <a:solidFill>
+                  <a:srgbClr val="B5402A"/>
+                </a:solidFill>
+                <a:latin typeface="Consolas"/>
+              </a:rPr>
+              <a:t>SUELTO · RADIO 25 KM · NO CIERRA</a:t>
+            </a:r>
+          </a:p>
+        </p:txBody>
+      </p:sp>
+      <p:sp>
+        <p:nvSpPr>
+          <p:cNvPr id="6" name="TextBox 5"/>
+          <p:cNvSpPr txBox="1"/>
+          <p:nvPr/>
+        </p:nvSpPr>
+        <p:spPr>
+          <a:xfrm>
+            <a:off x="660400" y="5435600"/>
+            <a:ext cx="5080000" cy="482600"/>
+          </a:xfrm>
+          <a:prstGeom prst="rect">
+            <a:avLst/>
+          </a:prstGeom>
+          <a:noFill/>
+        </p:spPr>
+        <p:txBody>
+          <a:bodyPr wrap="square" lIns="0" rIns="0" tIns="0" bIns="0" anchor="t">
+            <a:noAutofit/>
+          </a:bodyPr>
+          <a:lstStyle/>
+          <a:p>
+            <a:pPr algn="l">
+              <a:lnSpc>
+                <a:spcPct val="105000"/>
+              </a:lnSpc>
+            </a:pPr>
+            <a:r>
+              <a:rPr sz="2400" b="1">
+                <a:solidFill>
+                  <a:srgbClr val="B5402A"/>
+                </a:solidFill>
+                <a:latin typeface="Consolas"/>
+              </a:rPr>
+              <a:t>-$ 2,26 M / mes (-281 %)</a:t>
+            </a:r>
+          </a:p>
+        </p:txBody>
+      </p:sp>
       <p:pic>
         <p:nvPicPr>
-          <p:cNvPr id="4" name="Picture 3" descr="03-pellet.jpg"/>
+          <p:cNvPr id="7" name="Picture 6" descr="03-pellet.png"/>
           <p:cNvPicPr>
             <a:picLocks noChangeAspect="1"/>
           </p:cNvPicPr>
@@ -5321,36 +5941,36 @@
         </p:nvPicPr>
         <p:blipFill>
           <a:blip r:embed="rId3"/>
-          <a:srcRect t="15585" b="28943"/>
+          <a:srcRect/>
           <a:stretch>
             <a:fillRect/>
           </a:stretch>
         </p:blipFill>
         <p:spPr>
           <a:xfrm>
-            <a:off x="6273800" y="1651000"/>
-            <a:ext cx="5207000" cy="2222500"/>
-          </a:xfrm>
-          <a:prstGeom prst="rect">
-            <a:avLst/>
-          </a:prstGeom>
-          <a:ln w="9525">
+            <a:off x="6096000" y="1968500"/>
+            <a:ext cx="5080000" cy="2857500"/>
+          </a:xfrm>
+          <a:prstGeom prst="rect">
+            <a:avLst/>
+          </a:prstGeom>
+          <a:ln w="19050">
             <a:solidFill>
-              <a:srgbClr val="DFE4E1"/>
+              <a:srgbClr val="2150E8"/>
             </a:solidFill>
           </a:ln>
         </p:spPr>
       </p:pic>
       <p:sp>
         <p:nvSpPr>
-          <p:cNvPr id="5" name="TextBox 4"/>
+          <p:cNvPr id="8" name="TextBox 7"/>
           <p:cNvSpPr txBox="1"/>
           <p:nvPr/>
         </p:nvSpPr>
         <p:spPr>
           <a:xfrm>
-            <a:off x="711200" y="3962400"/>
-            <a:ext cx="5207000" cy="355600"/>
+            <a:off x="6096000" y="4953000"/>
+            <a:ext cx="5080000" cy="381000"/>
           </a:xfrm>
           <a:prstGeom prst="rect">
             <a:avLst/>
@@ -5365,31 +5985,31 @@
           <a:p>
             <a:pPr algn="l">
               <a:lnSpc>
-                <a:spcPct val="100000"/>
+                <a:spcPct val="105000"/>
               </a:lnSpc>
             </a:pPr>
             <a:r>
-              <a:rPr sz="2000" b="0" spc="160">
-                <a:solidFill>
-                  <a:srgbClr val="A5523C"/>
-                </a:solidFill>
-                <a:latin typeface="Geist Mono"/>
+              <a:rPr sz="2000" b="1" spc="80">
+                <a:solidFill>
+                  <a:srgbClr val="17784A"/>
+                </a:solidFill>
+                <a:latin typeface="Consolas"/>
               </a:rPr>
-              <a:t>SUELTO</a:t>
-            </a:r>
-          </a:p>
-        </p:txBody>
-      </p:sp>
-      <p:sp>
-        <p:nvSpPr>
-          <p:cNvPr id="6" name="TextBox 5"/>
+              <a:t>PELLET · RADIO 310 KM · CIERRA</a:t>
+            </a:r>
+          </a:p>
+        </p:txBody>
+      </p:sp>
+      <p:sp>
+        <p:nvSpPr>
+          <p:cNvPr id="9" name="TextBox 8"/>
           <p:cNvSpPr txBox="1"/>
           <p:nvPr/>
         </p:nvSpPr>
         <p:spPr>
           <a:xfrm>
-            <a:off x="6273800" y="3962400"/>
-            <a:ext cx="5207000" cy="355600"/>
+            <a:off x="6096000" y="5435600"/>
+            <a:ext cx="3810000" cy="482600"/>
           </a:xfrm>
           <a:prstGeom prst="rect">
             <a:avLst/>
@@ -5404,241 +6024,24 @@
           <a:p>
             <a:pPr algn="l">
               <a:lnSpc>
-                <a:spcPct val="100000"/>
+                <a:spcPct val="105000"/>
               </a:lnSpc>
             </a:pPr>
             <a:r>
-              <a:rPr sz="2000" b="0" spc="160">
-                <a:solidFill>
-                  <a:srgbClr val="3A7254"/>
-                </a:solidFill>
-                <a:latin typeface="Geist Mono"/>
+              <a:rPr sz="2400" b="1">
+                <a:solidFill>
+                  <a:srgbClr val="17784A"/>
+                </a:solidFill>
+                <a:latin typeface="Consolas"/>
               </a:rPr>
-              <a:t>PELLET</a:t>
-            </a:r>
-          </a:p>
-        </p:txBody>
-      </p:sp>
-      <p:sp>
-        <p:nvSpPr>
-          <p:cNvPr id="7" name="TextBox 6"/>
-          <p:cNvSpPr txBox="1"/>
-          <p:nvPr/>
-        </p:nvSpPr>
-        <p:spPr>
-          <a:xfrm>
-            <a:off x="711200" y="4445000"/>
-            <a:ext cx="6477000" cy="1117600"/>
-          </a:xfrm>
-          <a:prstGeom prst="rect">
-            <a:avLst/>
-          </a:prstGeom>
-          <a:noFill/>
-        </p:spPr>
-        <p:txBody>
-          <a:bodyPr wrap="square" lIns="0" rIns="0" tIns="0" bIns="0" anchor="t">
-            <a:noAutofit/>
-          </a:bodyPr>
-          <a:lstStyle/>
-          <a:p>
-            <a:pPr algn="l">
-              <a:lnSpc>
-                <a:spcPct val="100000"/>
-              </a:lnSpc>
-            </a:pPr>
-            <a:r>
-              <a:rPr sz="6600" b="1">
-                <a:solidFill>
-                  <a:srgbClr val="A5523C"/>
-                </a:solidFill>
-                <a:latin typeface="Geist Mono"/>
-              </a:rPr>
-              <a:t>25</a:t>
-            </a:r>
-            <a:r>
-              <a:rPr sz="6600" b="1">
-                <a:solidFill>
-                  <a:srgbClr val="141A17"/>
-                </a:solidFill>
-                <a:latin typeface="Geist Mono"/>
-              </a:rPr>
-              <a:t> → </a:t>
-            </a:r>
-            <a:r>
-              <a:rPr sz="6600" b="1">
-                <a:solidFill>
-                  <a:srgbClr val="3A7254"/>
-                </a:solidFill>
-                <a:latin typeface="Geist Mono"/>
-              </a:rPr>
-              <a:t>310 km</a:t>
-            </a:r>
-          </a:p>
-        </p:txBody>
-      </p:sp>
-      <p:sp>
-        <p:nvSpPr>
-          <p:cNvPr id="8" name="TextBox 7"/>
-          <p:cNvSpPr txBox="1"/>
-          <p:nvPr/>
-        </p:nvSpPr>
-        <p:spPr>
-          <a:xfrm>
-            <a:off x="711200" y="5613400"/>
-            <a:ext cx="6477000" cy="406400"/>
-          </a:xfrm>
-          <a:prstGeom prst="rect">
-            <a:avLst/>
-          </a:prstGeom>
-          <a:noFill/>
-        </p:spPr>
-        <p:txBody>
-          <a:bodyPr wrap="square" lIns="0" rIns="0" tIns="0" bIns="0" anchor="t">
-            <a:noAutofit/>
-          </a:bodyPr>
-          <a:lstStyle/>
-          <a:p>
-            <a:pPr algn="l">
-              <a:lnSpc>
-                <a:spcPct val="110000"/>
-              </a:lnSpc>
-            </a:pPr>
-            <a:r>
-              <a:rPr sz="2000" b="0">
-                <a:solidFill>
-                  <a:srgbClr val="55605B"/>
-                </a:solidFill>
-                <a:latin typeface="Geist"/>
-              </a:rPr>
-              <a:t>~12 veces más radio. Ejemplo con supuestos estimados.</a:t>
-            </a:r>
-          </a:p>
-        </p:txBody>
-      </p:sp>
-      <p:sp>
-        <p:nvSpPr>
-          <p:cNvPr id="9" name="TextBox 8"/>
-          <p:cNvSpPr txBox="1"/>
-          <p:nvPr/>
-        </p:nvSpPr>
-        <p:spPr>
-          <a:xfrm>
-            <a:off x="7366000" y="4445000"/>
-            <a:ext cx="4114800" cy="571500"/>
-          </a:xfrm>
-          <a:prstGeom prst="rect">
-            <a:avLst/>
-          </a:prstGeom>
-          <a:noFill/>
-        </p:spPr>
-        <p:txBody>
-          <a:bodyPr wrap="square" lIns="0" rIns="0" tIns="0" bIns="0" anchor="t">
-            <a:noAutofit/>
-          </a:bodyPr>
-          <a:lstStyle/>
-          <a:p>
-            <a:pPr algn="l">
-              <a:lnSpc>
-                <a:spcPct val="100000"/>
-              </a:lnSpc>
-            </a:pPr>
-            <a:r>
-              <a:rPr sz="3200" b="1" spc="-80">
-                <a:solidFill>
-                  <a:srgbClr val="141A17"/>
-                </a:solidFill>
-                <a:latin typeface="Geist"/>
-              </a:rPr>
-              <a:t>De </a:t>
-            </a:r>
-            <a:r>
-              <a:rPr sz="3200" b="1" spc="-80">
-                <a:solidFill>
-                  <a:srgbClr val="A5523C"/>
-                </a:solidFill>
-                <a:latin typeface="Geist"/>
-              </a:rPr>
-              <a:t>rojo</a:t>
-            </a:r>
-            <a:r>
-              <a:rPr sz="3200" b="1" spc="-80">
-                <a:solidFill>
-                  <a:srgbClr val="141A17"/>
-                </a:solidFill>
-                <a:latin typeface="Geist"/>
-              </a:rPr>
-              <a:t> a </a:t>
-            </a:r>
-            <a:r>
-              <a:rPr sz="3200" b="1" spc="-80">
-                <a:solidFill>
-                  <a:srgbClr val="3A7254"/>
-                </a:solidFill>
-                <a:latin typeface="Geist"/>
-              </a:rPr>
-              <a:t>verde</a:t>
-            </a:r>
-          </a:p>
-        </p:txBody>
-      </p:sp>
-      <p:sp>
-        <p:nvSpPr>
-          <p:cNvPr id="10" name="TextBox 9"/>
-          <p:cNvSpPr txBox="1"/>
-          <p:nvPr/>
-        </p:nvSpPr>
-        <p:spPr>
-          <a:xfrm>
-            <a:off x="7366000" y="5080000"/>
-            <a:ext cx="4114800" cy="889000"/>
-          </a:xfrm>
-          <a:prstGeom prst="rect">
-            <a:avLst/>
-          </a:prstGeom>
-          <a:noFill/>
-        </p:spPr>
-        <p:txBody>
-          <a:bodyPr wrap="square" lIns="0" rIns="0" tIns="0" bIns="0" anchor="t">
-            <a:noAutofit/>
-          </a:bodyPr>
-          <a:lstStyle/>
-          <a:p>
-            <a:pPr algn="l">
-              <a:lnSpc>
-                <a:spcPct val="115000"/>
-              </a:lnSpc>
-            </a:pPr>
-            <a:r>
-              <a:rPr sz="2200" b="0">
-                <a:solidFill>
-                  <a:srgbClr val="55605B"/>
-                </a:solidFill>
-                <a:latin typeface="Geist"/>
-              </a:rPr>
-              <a:t>Ahorro frente al GLP,</a:t>
-            </a:r>
-          </a:p>
-          <a:p>
-            <a:pPr algn="l">
-              <a:lnSpc>
-                <a:spcPct val="115000"/>
-              </a:lnSpc>
-            </a:pPr>
-            <a:r>
-              <a:rPr sz="2200" b="0">
-                <a:solidFill>
-                  <a:srgbClr val="55605B"/>
-                </a:solidFill>
-                <a:latin typeface="Geist"/>
-              </a:rPr>
-              <a:t>visible al instante</a:t>
+              <a:t>+$ 1,93 M / mes</a:t>
             </a:r>
           </a:p>
         </p:txBody>
       </p:sp>
       <p:pic>
         <p:nvPicPr>
-          <p:cNvPr id="11" name="Picture 10" descr="icon.png"/>
+          <p:cNvPr id="10" name="Picture 9" descr="icon.png"/>
           <p:cNvPicPr>
             <a:picLocks noChangeAspect="1"/>
           </p:cNvPicPr>
@@ -5653,7 +6056,7 @@
         </p:blipFill>
         <p:spPr>
           <a:xfrm>
-            <a:off x="11074400" y="609600"/>
+            <a:off x="11176000" y="558800"/>
             <a:ext cx="406400" cy="406400"/>
           </a:xfrm>
           <a:prstGeom prst="rect">
@@ -5663,14 +6066,14 @@
       </p:pic>
       <p:sp>
         <p:nvSpPr>
-          <p:cNvPr id="12" name="TextBox 11"/>
+          <p:cNvPr id="11" name="TextBox 10"/>
           <p:cNvSpPr txBox="1"/>
           <p:nvPr/>
         </p:nvSpPr>
         <p:spPr>
           <a:xfrm>
-            <a:off x="10210800" y="6032500"/>
-            <a:ext cx="1270000" cy="254000"/>
+            <a:off x="10033000" y="5943600"/>
+            <a:ext cx="1549400" cy="342900"/>
           </a:xfrm>
           <a:prstGeom prst="rect">
             <a:avLst/>
@@ -5685,17 +6088,17 @@
           <a:p>
             <a:pPr algn="r">
               <a:lnSpc>
-                <a:spcPct val="100000"/>
+                <a:spcPct val="105000"/>
               </a:lnSpc>
             </a:pPr>
             <a:r>
-              <a:rPr sz="1400" b="0">
-                <a:solidFill>
-                  <a:srgbClr val="5F6A65"/>
-                </a:solidFill>
-                <a:latin typeface="Geist Mono"/>
+              <a:rPr sz="1600" b="1">
+                <a:solidFill>
+                  <a:srgbClr val="5B6B94"/>
+                </a:solidFill>
+                <a:latin typeface="Consolas"/>
               </a:rPr>
-              <a:t>05 / 07</a:t>
+              <a:t>05 / 08</a:t>
             </a:r>
           </a:p>
         </p:txBody>
@@ -5714,7 +6117,7 @@
     <p:bg>
       <p:bgPr>
         <a:solidFill>
-          <a:srgbClr val="F7F8F7"/>
+          <a:srgbClr val="EEF3FD"/>
         </a:solidFill>
         <a:effectLst/>
       </p:bgPr>
@@ -5734,8 +6137,8 @@
         </p:nvSpPr>
         <p:spPr>
           <a:xfrm>
-            <a:off x="711200" y="698500"/>
-            <a:ext cx="9906000" cy="889000"/>
+            <a:off x="660400" y="609600"/>
+            <a:ext cx="4826000" cy="406400"/>
           </a:xfrm>
           <a:prstGeom prst="rect">
             <a:avLst/>
@@ -5750,24 +6153,270 @@
           <a:p>
             <a:pPr algn="l">
               <a:lnSpc>
-                <a:spcPct val="100000"/>
+                <a:spcPct val="105000"/>
               </a:lnSpc>
             </a:pPr>
             <a:r>
-              <a:rPr sz="4800" b="1" spc="-120">
-                <a:solidFill>
-                  <a:srgbClr val="141A17"/>
-                </a:solidFill>
-                <a:latin typeface="Geist"/>
+              <a:rPr sz="2000" b="1" spc="80">
+                <a:solidFill>
+                  <a:srgbClr val="2150E8"/>
+                </a:solidFill>
+                <a:latin typeface="Consolas"/>
               </a:rPr>
-              <a:t>Publicá. Conectá. Te avisamos.</a:t>
+              <a:t>05 · AHORRO Y FUENTES</a:t>
+            </a:r>
+          </a:p>
+        </p:txBody>
+      </p:sp>
+      <p:sp>
+        <p:nvSpPr>
+          <p:cNvPr id="3" name="Rectangle 2"/>
+          <p:cNvSpPr/>
+          <p:nvPr/>
+        </p:nvSpPr>
+        <p:spPr>
+          <a:xfrm>
+            <a:off x="660400" y="1168400"/>
+            <a:ext cx="4572000" cy="2095500"/>
+          </a:xfrm>
+          <a:prstGeom prst="rect">
+            <a:avLst/>
+          </a:prstGeom>
+          <a:solidFill>
+            <a:srgbClr val="0B1640"/>
+          </a:solidFill>
+          <a:ln>
+            <a:noFill/>
+          </a:ln>
+          <a:effectLst/>
+        </p:spPr>
+        <p:style>
+          <a:lnRef idx="1">
+            <a:schemeClr val="accent1"/>
+          </a:lnRef>
+          <a:fillRef idx="3">
+            <a:schemeClr val="accent1"/>
+          </a:fillRef>
+          <a:effectRef idx="2">
+            <a:schemeClr val="accent1"/>
+          </a:effectRef>
+          <a:fontRef idx="minor">
+            <a:schemeClr val="lt1"/>
+          </a:fontRef>
+        </p:style>
+        <p:txBody>
+          <a:bodyPr rtlCol="0" anchor="ctr"/>
+          <a:lstStyle/>
+          <a:p>
+            <a:pPr algn="ctr"/>
+          </a:p>
+        </p:txBody>
+      </p:sp>
+      <p:sp>
+        <p:nvSpPr>
+          <p:cNvPr id="4" name="TextBox 3"/>
+          <p:cNvSpPr txBox="1"/>
+          <p:nvPr/>
+        </p:nvSpPr>
+        <p:spPr>
+          <a:xfrm>
+            <a:off x="914400" y="1346200"/>
+            <a:ext cx="4064000" cy="762000"/>
+          </a:xfrm>
+          <a:prstGeom prst="rect">
+            <a:avLst/>
+          </a:prstGeom>
+          <a:noFill/>
+        </p:spPr>
+        <p:txBody>
+          <a:bodyPr wrap="square" lIns="0" rIns="0" tIns="0" bIns="0" anchor="t">
+            <a:noAutofit/>
+          </a:bodyPr>
+          <a:lstStyle/>
+          <a:p>
+            <a:pPr algn="l">
+              <a:lnSpc>
+                <a:spcPct val="105000"/>
+              </a:lnSpc>
+            </a:pPr>
+            <a:r>
+              <a:rPr sz="3800" b="1">
+                <a:solidFill>
+                  <a:srgbClr val="7AA7FF"/>
+                </a:solidFill>
+                <a:latin typeface="Consolas"/>
+              </a:rPr>
+              <a:t>-$ 15 M / mes</a:t>
+            </a:r>
+          </a:p>
+        </p:txBody>
+      </p:sp>
+      <p:sp>
+        <p:nvSpPr>
+          <p:cNvPr id="5" name="TextBox 4"/>
+          <p:cNvSpPr txBox="1"/>
+          <p:nvPr/>
+        </p:nvSpPr>
+        <p:spPr>
+          <a:xfrm>
+            <a:off x="914400" y="2235200"/>
+            <a:ext cx="4064000" cy="889000"/>
+          </a:xfrm>
+          <a:prstGeom prst="rect">
+            <a:avLst/>
+          </a:prstGeom>
+          <a:noFill/>
+        </p:spPr>
+        <p:txBody>
+          <a:bodyPr wrap="square" lIns="0" rIns="0" tIns="0" bIns="0" anchor="t">
+            <a:noAutofit/>
+          </a:bodyPr>
+          <a:lstStyle/>
+          <a:p>
+            <a:pPr algn="l">
+              <a:lnSpc>
+                <a:spcPct val="112000"/>
+              </a:lnSpc>
+            </a:pPr>
+            <a:r>
+              <a:rPr sz="2100" b="0">
+                <a:solidFill>
+                  <a:srgbClr val="FFFFFF"/>
+                </a:solidFill>
+                <a:latin typeface="Segoe UI"/>
+              </a:rPr>
+              <a:t>Ahorra el frigorífico frente al gas envasado (GLP).</a:t>
+            </a:r>
+          </a:p>
+        </p:txBody>
+      </p:sp>
+      <p:sp>
+        <p:nvSpPr>
+          <p:cNvPr id="6" name="Rectangle 5"/>
+          <p:cNvSpPr/>
+          <p:nvPr/>
+        </p:nvSpPr>
+        <p:spPr>
+          <a:xfrm>
+            <a:off x="660400" y="3454400"/>
+            <a:ext cx="4572000" cy="2286000"/>
+          </a:xfrm>
+          <a:prstGeom prst="rect">
+            <a:avLst/>
+          </a:prstGeom>
+          <a:solidFill>
+            <a:srgbClr val="FFFFFF"/>
+          </a:solidFill>
+          <a:ln w="12700">
+            <a:solidFill>
+              <a:srgbClr val="D3DEF3"/>
+            </a:solidFill>
+          </a:ln>
+          <a:effectLst/>
+        </p:spPr>
+        <p:style>
+          <a:lnRef idx="1">
+            <a:schemeClr val="accent1"/>
+          </a:lnRef>
+          <a:fillRef idx="3">
+            <a:schemeClr val="accent1"/>
+          </a:fillRef>
+          <a:effectRef idx="2">
+            <a:schemeClr val="accent1"/>
+          </a:effectRef>
+          <a:fontRef idx="minor">
+            <a:schemeClr val="lt1"/>
+          </a:fontRef>
+        </p:style>
+        <p:txBody>
+          <a:bodyPr rtlCol="0" anchor="ctr"/>
+          <a:lstStyle/>
+          <a:p>
+            <a:pPr algn="ctr"/>
+          </a:p>
+        </p:txBody>
+      </p:sp>
+      <p:sp>
+        <p:nvSpPr>
+          <p:cNvPr id="7" name="TextBox 6"/>
+          <p:cNvSpPr txBox="1"/>
+          <p:nvPr/>
+        </p:nvSpPr>
+        <p:spPr>
+          <a:xfrm>
+            <a:off x="914400" y="3657600"/>
+            <a:ext cx="4064000" cy="406400"/>
+          </a:xfrm>
+          <a:prstGeom prst="rect">
+            <a:avLst/>
+          </a:prstGeom>
+          <a:noFill/>
+        </p:spPr>
+        <p:txBody>
+          <a:bodyPr wrap="square" lIns="0" rIns="0" tIns="0" bIns="0" anchor="t">
+            <a:noAutofit/>
+          </a:bodyPr>
+          <a:lstStyle/>
+          <a:p>
+            <a:pPr algn="l">
+              <a:lnSpc>
+                <a:spcPct val="105000"/>
+              </a:lnSpc>
+            </a:pPr>
+            <a:r>
+              <a:rPr sz="2000" b="1" spc="80">
+                <a:solidFill>
+                  <a:srgbClr val="2150E8"/>
+                </a:solidFill>
+                <a:latin typeface="Consolas"/>
+              </a:rPr>
+              <a:t>CADA NÚMERO CON SU FUENTE</a:t>
+            </a:r>
+          </a:p>
+        </p:txBody>
+      </p:sp>
+      <p:sp>
+        <p:nvSpPr>
+          <p:cNvPr id="8" name="TextBox 7"/>
+          <p:cNvSpPr txBox="1"/>
+          <p:nvPr/>
+        </p:nvSpPr>
+        <p:spPr>
+          <a:xfrm>
+            <a:off x="914400" y="4191000"/>
+            <a:ext cx="4064000" cy="1333500"/>
+          </a:xfrm>
+          <a:prstGeom prst="rect">
+            <a:avLst/>
+          </a:prstGeom>
+          <a:noFill/>
+        </p:spPr>
+        <p:txBody>
+          <a:bodyPr wrap="square" lIns="0" rIns="0" tIns="0" bIns="0" anchor="t">
+            <a:noAutofit/>
+          </a:bodyPr>
+          <a:lstStyle/>
+          <a:p>
+            <a:pPr algn="l">
+              <a:lnSpc>
+                <a:spcPct val="112000"/>
+              </a:lnSpc>
+            </a:pPr>
+            <a:r>
+              <a:rPr sz="2100" b="0">
+                <a:solidFill>
+                  <a:srgbClr val="3D4D7A"/>
+                </a:solidFill>
+                <a:latin typeface="Segoe UI"/>
+              </a:rPr>
+              <a:t>Tarifas FETRA 2026, GLP 2026, CONICET e IPCC con etiqueta Real o Estimado.</a:t>
             </a:r>
           </a:p>
         </p:txBody>
       </p:sp>
       <p:pic>
         <p:nvPicPr>
-          <p:cNvPr id="3" name="Picture 2" descr="04-publicar.jpg"/>
+          <p:cNvPr id="9" name="Picture 8" descr="07-fuentes.png"/>
           <p:cNvPicPr>
             <a:picLocks noChangeAspect="1"/>
           </p:cNvPicPr>
@@ -5775,213 +6424,6 @@
         </p:nvPicPr>
         <p:blipFill>
           <a:blip r:embed="rId2"/>
-          <a:srcRect b="37828"/>
-          <a:stretch>
-            <a:fillRect/>
-          </a:stretch>
-        </p:blipFill>
-        <p:spPr>
-          <a:xfrm>
-            <a:off x="711200" y="1714500"/>
-            <a:ext cx="3352800" cy="3429000"/>
-          </a:xfrm>
-          <a:prstGeom prst="rect">
-            <a:avLst/>
-          </a:prstGeom>
-          <a:ln w="9525">
-            <a:solidFill>
-              <a:srgbClr val="DFE4E1"/>
-            </a:solidFill>
-          </a:ln>
-        </p:spPr>
-      </p:pic>
-      <p:pic>
-        <p:nvPicPr>
-          <p:cNvPr id="4" name="Picture 3" descr="05-contacto.jpg"/>
-          <p:cNvPicPr>
-            <a:picLocks noChangeAspect="1"/>
-          </p:cNvPicPr>
-          <p:nvPr/>
-        </p:nvPicPr>
-        <p:blipFill>
-          <a:blip r:embed="rId3"/>
-          <a:srcRect b="33610"/>
-          <a:stretch>
-            <a:fillRect/>
-          </a:stretch>
-        </p:blipFill>
-        <p:spPr>
-          <a:xfrm>
-            <a:off x="4419600" y="1714500"/>
-            <a:ext cx="3352800" cy="3429000"/>
-          </a:xfrm>
-          <a:prstGeom prst="rect">
-            <a:avLst/>
-          </a:prstGeom>
-          <a:ln w="9525">
-            <a:solidFill>
-              <a:srgbClr val="DFE4E1"/>
-            </a:solidFill>
-          </a:ln>
-        </p:spPr>
-      </p:pic>
-      <p:pic>
-        <p:nvPicPr>
-          <p:cNvPr id="5" name="Picture 4" descr="06-campanita.jpg"/>
-          <p:cNvPicPr>
-            <a:picLocks noChangeAspect="1"/>
-          </p:cNvPicPr>
-          <p:nvPr/>
-        </p:nvPicPr>
-        <p:blipFill>
-          <a:blip r:embed="rId4"/>
-          <a:srcRect l="31988" r="31988"/>
-          <a:stretch>
-            <a:fillRect/>
-          </a:stretch>
-        </p:blipFill>
-        <p:spPr>
-          <a:xfrm>
-            <a:off x="8128000" y="1714500"/>
-            <a:ext cx="3352800" cy="3429000"/>
-          </a:xfrm>
-          <a:prstGeom prst="rect">
-            <a:avLst/>
-          </a:prstGeom>
-          <a:ln w="9525">
-            <a:solidFill>
-              <a:srgbClr val="DFE4E1"/>
-            </a:solidFill>
-          </a:ln>
-        </p:spPr>
-      </p:pic>
-      <p:sp>
-        <p:nvSpPr>
-          <p:cNvPr id="6" name="TextBox 5"/>
-          <p:cNvSpPr txBox="1"/>
-          <p:nvPr/>
-        </p:nvSpPr>
-        <p:spPr>
-          <a:xfrm>
-            <a:off x="711200" y="5308600"/>
-            <a:ext cx="3352800" cy="444500"/>
-          </a:xfrm>
-          <a:prstGeom prst="rect">
-            <a:avLst/>
-          </a:prstGeom>
-          <a:noFill/>
-        </p:spPr>
-        <p:txBody>
-          <a:bodyPr wrap="square" lIns="0" rIns="0" tIns="0" bIns="0" anchor="t">
-            <a:noAutofit/>
-          </a:bodyPr>
-          <a:lstStyle/>
-          <a:p>
-            <a:pPr algn="l">
-              <a:lnSpc>
-                <a:spcPct val="100000"/>
-              </a:lnSpc>
-            </a:pPr>
-            <a:r>
-              <a:rPr sz="2200" b="1">
-                <a:solidFill>
-                  <a:srgbClr val="141A17"/>
-                </a:solidFill>
-                <a:latin typeface="Geist"/>
-              </a:rPr>
-              <a:t>En un minuto</a:t>
-            </a:r>
-          </a:p>
-        </p:txBody>
-      </p:sp>
-      <p:sp>
-        <p:nvSpPr>
-          <p:cNvPr id="7" name="TextBox 6"/>
-          <p:cNvSpPr txBox="1"/>
-          <p:nvPr/>
-        </p:nvSpPr>
-        <p:spPr>
-          <a:xfrm>
-            <a:off x="4419600" y="5308600"/>
-            <a:ext cx="3352800" cy="444500"/>
-          </a:xfrm>
-          <a:prstGeom prst="rect">
-            <a:avLst/>
-          </a:prstGeom>
-          <a:noFill/>
-        </p:spPr>
-        <p:txBody>
-          <a:bodyPr wrap="square" lIns="0" rIns="0" tIns="0" bIns="0" anchor="t">
-            <a:noAutofit/>
-          </a:bodyPr>
-          <a:lstStyle/>
-          <a:p>
-            <a:pPr algn="l">
-              <a:lnSpc>
-                <a:spcPct val="100000"/>
-              </a:lnSpc>
-            </a:pPr>
-            <a:r>
-              <a:rPr sz="2200" b="1">
-                <a:solidFill>
-                  <a:srgbClr val="141A17"/>
-                </a:solidFill>
-                <a:latin typeface="Geist"/>
-              </a:rPr>
-              <a:t>WhatsApp en un click</a:t>
-            </a:r>
-          </a:p>
-        </p:txBody>
-      </p:sp>
-      <p:sp>
-        <p:nvSpPr>
-          <p:cNvPr id="8" name="TextBox 7"/>
-          <p:cNvSpPr txBox="1"/>
-          <p:nvPr/>
-        </p:nvSpPr>
-        <p:spPr>
-          <a:xfrm>
-            <a:off x="8128000" y="5308600"/>
-            <a:ext cx="3352800" cy="444500"/>
-          </a:xfrm>
-          <a:prstGeom prst="rect">
-            <a:avLst/>
-          </a:prstGeom>
-          <a:noFill/>
-        </p:spPr>
-        <p:txBody>
-          <a:bodyPr wrap="square" lIns="0" rIns="0" tIns="0" bIns="0" anchor="t">
-            <a:noAutofit/>
-          </a:bodyPr>
-          <a:lstStyle/>
-          <a:p>
-            <a:pPr algn="l">
-              <a:lnSpc>
-                <a:spcPct val="100000"/>
-              </a:lnSpc>
-            </a:pPr>
-            <a:r>
-              <a:rPr sz="2200" b="1">
-                <a:solidFill>
-                  <a:srgbClr val="141A17"/>
-                </a:solidFill>
-                <a:latin typeface="Geist"/>
-              </a:rPr>
-              <a:t>Aviso de match</a:t>
-            </a:r>
-          </a:p>
-        </p:txBody>
-      </p:sp>
-      <p:pic>
-        <p:nvPicPr>
-          <p:cNvPr id="9" name="Picture 8" descr="icon.png"/>
-          <p:cNvPicPr>
-            <a:picLocks noChangeAspect="1"/>
-          </p:cNvPicPr>
-          <p:nvPr/>
-        </p:nvPicPr>
-        <p:blipFill>
-          <a:blip r:embed="rId5"/>
           <a:srcRect/>
           <a:stretch>
             <a:fillRect/>
@@ -5989,7 +6431,37 @@
         </p:blipFill>
         <p:spPr>
           <a:xfrm>
-            <a:off x="11074400" y="609600"/>
+            <a:off x="5435600" y="1651000"/>
+            <a:ext cx="6096000" cy="3429000"/>
+          </a:xfrm>
+          <a:prstGeom prst="rect">
+            <a:avLst/>
+          </a:prstGeom>
+          <a:ln w="19050">
+            <a:solidFill>
+              <a:srgbClr val="2150E8"/>
+            </a:solidFill>
+          </a:ln>
+        </p:spPr>
+      </p:pic>
+      <p:pic>
+        <p:nvPicPr>
+          <p:cNvPr id="10" name="Picture 9" descr="icon.png"/>
+          <p:cNvPicPr>
+            <a:picLocks noChangeAspect="1"/>
+          </p:cNvPicPr>
+          <p:nvPr/>
+        </p:nvPicPr>
+        <p:blipFill>
+          <a:blip r:embed="rId3"/>
+          <a:srcRect/>
+          <a:stretch>
+            <a:fillRect/>
+          </a:stretch>
+        </p:blipFill>
+        <p:spPr>
+          <a:xfrm>
+            <a:off x="11176000" y="558800"/>
             <a:ext cx="406400" cy="406400"/>
           </a:xfrm>
           <a:prstGeom prst="rect">
@@ -5999,14 +6471,14 @@
       </p:pic>
       <p:sp>
         <p:nvSpPr>
-          <p:cNvPr id="10" name="TextBox 9"/>
+          <p:cNvPr id="11" name="TextBox 10"/>
           <p:cNvSpPr txBox="1"/>
           <p:nvPr/>
         </p:nvSpPr>
         <p:spPr>
           <a:xfrm>
-            <a:off x="10210800" y="6032500"/>
-            <a:ext cx="1270000" cy="254000"/>
+            <a:off x="10033000" y="5943600"/>
+            <a:ext cx="1549400" cy="342900"/>
           </a:xfrm>
           <a:prstGeom prst="rect">
             <a:avLst/>
@@ -6021,17 +6493,17 @@
           <a:p>
             <a:pPr algn="r">
               <a:lnSpc>
-                <a:spcPct val="100000"/>
+                <a:spcPct val="105000"/>
               </a:lnSpc>
             </a:pPr>
             <a:r>
-              <a:rPr sz="1400" b="0">
-                <a:solidFill>
-                  <a:srgbClr val="5F6A65"/>
-                </a:solidFill>
-                <a:latin typeface="Geist Mono"/>
+              <a:rPr sz="1600" b="1">
+                <a:solidFill>
+                  <a:srgbClr val="5B6B94"/>
+                </a:solidFill>
+                <a:latin typeface="Consolas"/>
               </a:rPr>
-              <a:t>06 / 07</a:t>
+              <a:t>06 / 08</a:t>
             </a:r>
           </a:p>
         </p:txBody>
@@ -6050,7 +6522,7 @@
     <p:bg>
       <p:bgPr>
         <a:solidFill>
-          <a:srgbClr val="F7F8F7"/>
+          <a:srgbClr val="EEF3FD"/>
         </a:solidFill>
         <a:effectLst/>
       </p:bgPr>
@@ -6070,8 +6542,8 @@
         </p:nvSpPr>
         <p:spPr>
           <a:xfrm>
-            <a:off x="711200" y="698500"/>
-            <a:ext cx="9525000" cy="952500"/>
+            <a:off x="660400" y="609600"/>
+            <a:ext cx="9525000" cy="406400"/>
           </a:xfrm>
           <a:prstGeom prst="rect">
             <a:avLst/>
@@ -6086,26 +6558,63 @@
           <a:p>
             <a:pPr algn="l">
               <a:lnSpc>
-                <a:spcPct val="100000"/>
+                <a:spcPct val="105000"/>
               </a:lnSpc>
             </a:pPr>
             <a:r>
-              <a:rPr sz="5400" b="1" spc="-135">
-                <a:solidFill>
-                  <a:srgbClr val="141A17"/>
-                </a:solidFill>
-                <a:latin typeface="Geist"/>
+              <a:rPr sz="2000" b="1" spc="80">
+                <a:solidFill>
+                  <a:srgbClr val="2150E8"/>
+                </a:solidFill>
+                <a:latin typeface="Consolas"/>
               </a:rPr>
-              <a:t>Probalo ahora</a:t>
+              <a:t>06 · MERCADO ACTIVO E IMPACTO</a:t>
+            </a:r>
+          </a:p>
+        </p:txBody>
+      </p:sp>
+      <p:sp>
+        <p:nvSpPr>
+          <p:cNvPr id="3" name="TextBox 2"/>
+          <p:cNvSpPr txBox="1"/>
+          <p:nvPr/>
+        </p:nvSpPr>
+        <p:spPr>
+          <a:xfrm>
+            <a:off x="660400" y="1117600"/>
+            <a:ext cx="5080000" cy="660400"/>
+          </a:xfrm>
+          <a:prstGeom prst="rect">
+            <a:avLst/>
+          </a:prstGeom>
+          <a:noFill/>
+        </p:spPr>
+        <p:txBody>
+          <a:bodyPr wrap="square" lIns="0" rIns="0" tIns="0" bIns="0" anchor="t">
+            <a:noAutofit/>
+          </a:bodyPr>
+          <a:lstStyle/>
+          <a:p>
+            <a:pPr algn="l">
+              <a:lnSpc>
+                <a:spcPct val="105000"/>
+              </a:lnSpc>
+            </a:pPr>
+            <a:r>
+              <a:rPr sz="3400" b="1" spc="-68">
+                <a:solidFill>
+                  <a:srgbClr val="0A1433"/>
+                </a:solidFill>
+                <a:latin typeface="Segoe UI"/>
+              </a:rPr>
+              <a:t>Publicás en 1 minuto</a:t>
             </a:r>
           </a:p>
         </p:txBody>
       </p:sp>
       <p:pic>
         <p:nvPicPr>
-          <p:cNvPr id="3" name="Picture 2" descr="qr-demo.png">
-            <a:hlinkClick r:id="rId3"/>
-          </p:cNvPr>
+          <p:cNvPr id="4" name="Picture 3" descr="06-campanita.png"/>
           <p:cNvPicPr>
             <a:picLocks noChangeAspect="1"/>
           </p:cNvPicPr>
@@ -6120,29 +6629,29 @@
         </p:blipFill>
         <p:spPr>
           <a:xfrm>
-            <a:off x="711200" y="1905000"/>
-            <a:ext cx="2413000" cy="2413000"/>
-          </a:xfrm>
-          <a:prstGeom prst="rect">
-            <a:avLst/>
-          </a:prstGeom>
-          <a:ln w="9525">
+            <a:off x="660400" y="1905000"/>
+            <a:ext cx="5080000" cy="2857500"/>
+          </a:xfrm>
+          <a:prstGeom prst="rect">
+            <a:avLst/>
+          </a:prstGeom>
+          <a:ln w="19050">
             <a:solidFill>
-              <a:srgbClr val="DFE4E1"/>
+              <a:srgbClr val="2150E8"/>
             </a:solidFill>
           </a:ln>
         </p:spPr>
       </p:pic>
       <p:sp>
         <p:nvSpPr>
-          <p:cNvPr id="4" name="TextBox 3"/>
+          <p:cNvPr id="5" name="TextBox 4"/>
           <p:cNvSpPr txBox="1"/>
           <p:nvPr/>
         </p:nvSpPr>
         <p:spPr>
           <a:xfrm>
-            <a:off x="3556000" y="2095500"/>
-            <a:ext cx="7924800" cy="635000"/>
+            <a:off x="660400" y="4914900"/>
+            <a:ext cx="5080000" cy="889000"/>
           </a:xfrm>
           <a:prstGeom prst="rect">
             <a:avLst/>
@@ -6157,57 +6666,17 @@
           <a:p>
             <a:pPr algn="l">
               <a:lnSpc>
-                <a:spcPct val="100000"/>
+                <a:spcPct val="112000"/>
               </a:lnSpc>
             </a:pPr>
             <a:r>
-              <a:rPr sz="3200" b="1" spc="-80">
-                <a:solidFill>
-                  <a:srgbClr val="3A7254"/>
-                </a:solidFill>
-                <a:latin typeface="Geist"/>
-                <a:hlinkClick r:id="rId3"/>
+              <a:rPr sz="2100" b="0">
+                <a:solidFill>
+                  <a:srgbClr val="3D4D7A"/>
+                </a:solidFill>
+                <a:latin typeface="Segoe UI"/>
               </a:rPr>
-              <a:t>ideathon-agro-9u3t-flax.vercel.app</a:t>
-            </a:r>
-          </a:p>
-        </p:txBody>
-      </p:sp>
-      <p:sp>
-        <p:nvSpPr>
-          <p:cNvPr id="5" name="TextBox 4"/>
-          <p:cNvSpPr txBox="1"/>
-          <p:nvPr/>
-        </p:nvSpPr>
-        <p:spPr>
-          <a:xfrm>
-            <a:off x="3556000" y="2984500"/>
-            <a:ext cx="7924800" cy="571500"/>
-          </a:xfrm>
-          <a:prstGeom prst="rect">
-            <a:avLst/>
-          </a:prstGeom>
-          <a:noFill/>
-        </p:spPr>
-        <p:txBody>
-          <a:bodyPr wrap="square" lIns="0" rIns="0" tIns="0" bIns="0" anchor="t">
-            <a:noAutofit/>
-          </a:bodyPr>
-          <a:lstStyle/>
-          <a:p>
-            <a:pPr algn="l">
-              <a:lnSpc>
-                <a:spcPct val="100000"/>
-              </a:lnSpc>
-            </a:pPr>
-            <a:r>
-              <a:rPr sz="3200" b="1" spc="-80">
-                <a:solidFill>
-                  <a:srgbClr val="141A17"/>
-                </a:solidFill>
-                <a:latin typeface="Geist"/>
-              </a:rPr>
-              <a:t>Equipo 13</a:t>
+              <a:t>Sin cuenta: contacto directo por WhatsApp y alertas de negocio.</a:t>
             </a:r>
           </a:p>
         </p:txBody>
@@ -6220,17 +6689,19 @@
         </p:nvSpPr>
         <p:spPr>
           <a:xfrm>
-            <a:off x="711200" y="4826000"/>
-            <a:ext cx="10769600" cy="12700"/>
+            <a:off x="6096000" y="1117600"/>
+            <a:ext cx="5435600" cy="1473200"/>
           </a:xfrm>
           <a:prstGeom prst="rect">
             <a:avLst/>
           </a:prstGeom>
           <a:solidFill>
-            <a:srgbClr val="DFE4E1"/>
+            <a:srgbClr val="FFFFFF"/>
           </a:solidFill>
-          <a:ln>
-            <a:noFill/>
+          <a:ln w="12700">
+            <a:solidFill>
+              <a:srgbClr val="D3DEF3"/>
+            </a:solidFill>
           </a:ln>
           <a:effectLst/>
         </p:spPr>
@@ -6264,8 +6735,495 @@
         </p:nvSpPr>
         <p:spPr>
           <a:xfrm>
-            <a:off x="711200" y="5016500"/>
-            <a:ext cx="10769600" cy="952500"/>
+            <a:off x="6350000" y="1257300"/>
+            <a:ext cx="4927600" cy="381000"/>
+          </a:xfrm>
+          <a:prstGeom prst="rect">
+            <a:avLst/>
+          </a:prstGeom>
+          <a:noFill/>
+        </p:spPr>
+        <p:txBody>
+          <a:bodyPr wrap="square" lIns="0" rIns="0" tIns="0" bIns="0" anchor="t">
+            <a:noAutofit/>
+          </a:bodyPr>
+          <a:lstStyle/>
+          <a:p>
+            <a:pPr algn="l">
+              <a:lnSpc>
+                <a:spcPct val="105000"/>
+              </a:lnSpc>
+            </a:pPr>
+            <a:r>
+              <a:rPr sz="2000" b="1" spc="80">
+                <a:solidFill>
+                  <a:srgbClr val="2150E8"/>
+                </a:solidFill>
+                <a:latin typeface="Consolas"/>
+              </a:rPr>
+              <a:t>1 · FREEMIUM B2B + COMISIÓN</a:t>
+            </a:r>
+          </a:p>
+        </p:txBody>
+      </p:sp>
+      <p:sp>
+        <p:nvSpPr>
+          <p:cNvPr id="8" name="TextBox 7"/>
+          <p:cNvSpPr txBox="1"/>
+          <p:nvPr/>
+        </p:nvSpPr>
+        <p:spPr>
+          <a:xfrm>
+            <a:off x="6350000" y="1752600"/>
+            <a:ext cx="4927600" cy="762000"/>
+          </a:xfrm>
+          <a:prstGeom prst="rect">
+            <a:avLst/>
+          </a:prstGeom>
+          <a:noFill/>
+        </p:spPr>
+        <p:txBody>
+          <a:bodyPr wrap="square" lIns="0" rIns="0" tIns="0" bIns="0" anchor="t">
+            <a:noAutofit/>
+          </a:bodyPr>
+          <a:lstStyle/>
+          <a:p>
+            <a:pPr algn="l">
+              <a:lnSpc>
+                <a:spcPct val="105000"/>
+              </a:lnSpc>
+            </a:pPr>
+            <a:r>
+              <a:rPr sz="2000" b="0">
+                <a:solidFill>
+                  <a:srgbClr val="3D4D7A"/>
+                </a:solidFill>
+                <a:latin typeface="Segoe UI"/>
+              </a:rPr>
+              <a:t>Publicar gratis; plan pro y comisión por trato.</a:t>
+            </a:r>
+          </a:p>
+        </p:txBody>
+      </p:sp>
+      <p:sp>
+        <p:nvSpPr>
+          <p:cNvPr id="9" name="Rectangle 8"/>
+          <p:cNvSpPr/>
+          <p:nvPr/>
+        </p:nvSpPr>
+        <p:spPr>
+          <a:xfrm>
+            <a:off x="6096000" y="2743200"/>
+            <a:ext cx="5435600" cy="1473200"/>
+          </a:xfrm>
+          <a:prstGeom prst="rect">
+            <a:avLst/>
+          </a:prstGeom>
+          <a:solidFill>
+            <a:srgbClr val="FFFFFF"/>
+          </a:solidFill>
+          <a:ln w="12700">
+            <a:solidFill>
+              <a:srgbClr val="D3DEF3"/>
+            </a:solidFill>
+          </a:ln>
+          <a:effectLst/>
+        </p:spPr>
+        <p:style>
+          <a:lnRef idx="1">
+            <a:schemeClr val="accent1"/>
+          </a:lnRef>
+          <a:fillRef idx="3">
+            <a:schemeClr val="accent1"/>
+          </a:fillRef>
+          <a:effectRef idx="2">
+            <a:schemeClr val="accent1"/>
+          </a:effectRef>
+          <a:fontRef idx="minor">
+            <a:schemeClr val="lt1"/>
+          </a:fontRef>
+        </p:style>
+        <p:txBody>
+          <a:bodyPr rtlCol="0" anchor="ctr"/>
+          <a:lstStyle/>
+          <a:p>
+            <a:pPr algn="ctr"/>
+          </a:p>
+        </p:txBody>
+      </p:sp>
+      <p:sp>
+        <p:nvSpPr>
+          <p:cNvPr id="10" name="TextBox 9"/>
+          <p:cNvSpPr txBox="1"/>
+          <p:nvPr/>
+        </p:nvSpPr>
+        <p:spPr>
+          <a:xfrm>
+            <a:off x="6350000" y="2882900"/>
+            <a:ext cx="4927600" cy="381000"/>
+          </a:xfrm>
+          <a:prstGeom prst="rect">
+            <a:avLst/>
+          </a:prstGeom>
+          <a:noFill/>
+        </p:spPr>
+        <p:txBody>
+          <a:bodyPr wrap="square" lIns="0" rIns="0" tIns="0" bIns="0" anchor="t">
+            <a:noAutofit/>
+          </a:bodyPr>
+          <a:lstStyle/>
+          <a:p>
+            <a:pPr algn="l">
+              <a:lnSpc>
+                <a:spcPct val="105000"/>
+              </a:lnSpc>
+            </a:pPr>
+            <a:r>
+              <a:rPr sz="2000" b="1" spc="80">
+                <a:solidFill>
+                  <a:srgbClr val="2150E8"/>
+                </a:solidFill>
+                <a:latin typeface="Consolas"/>
+              </a:rPr>
+              <a:t>2 · TABLERO PARA CORRIENTES</a:t>
+            </a:r>
+          </a:p>
+        </p:txBody>
+      </p:sp>
+      <p:sp>
+        <p:nvSpPr>
+          <p:cNvPr id="11" name="TextBox 10"/>
+          <p:cNvSpPr txBox="1"/>
+          <p:nvPr/>
+        </p:nvSpPr>
+        <p:spPr>
+          <a:xfrm>
+            <a:off x="6350000" y="3378200"/>
+            <a:ext cx="4927600" cy="762000"/>
+          </a:xfrm>
+          <a:prstGeom prst="rect">
+            <a:avLst/>
+          </a:prstGeom>
+          <a:noFill/>
+        </p:spPr>
+        <p:txBody>
+          <a:bodyPr wrap="square" lIns="0" rIns="0" tIns="0" bIns="0" anchor="t">
+            <a:noAutofit/>
+          </a:bodyPr>
+          <a:lstStyle/>
+          <a:p>
+            <a:pPr algn="l">
+              <a:lnSpc>
+                <a:spcPct val="105000"/>
+              </a:lnSpc>
+            </a:pPr>
+            <a:r>
+              <a:rPr sz="2000" b="0">
+                <a:solidFill>
+                  <a:srgbClr val="3D4D7A"/>
+                </a:solidFill>
+                <a:latin typeface="Segoe UI"/>
+              </a:rPr>
+              <a:t>Menos humo, menos GLP y datos para planificar.</a:t>
+            </a:r>
+          </a:p>
+        </p:txBody>
+      </p:sp>
+      <p:sp>
+        <p:nvSpPr>
+          <p:cNvPr id="12" name="Rectangle 11"/>
+          <p:cNvSpPr/>
+          <p:nvPr/>
+        </p:nvSpPr>
+        <p:spPr>
+          <a:xfrm>
+            <a:off x="6096000" y="4368800"/>
+            <a:ext cx="5435600" cy="1422400"/>
+          </a:xfrm>
+          <a:prstGeom prst="rect">
+            <a:avLst/>
+          </a:prstGeom>
+          <a:solidFill>
+            <a:srgbClr val="0B1640"/>
+          </a:solidFill>
+          <a:ln>
+            <a:noFill/>
+          </a:ln>
+          <a:effectLst/>
+        </p:spPr>
+        <p:style>
+          <a:lnRef idx="1">
+            <a:schemeClr val="accent1"/>
+          </a:lnRef>
+          <a:fillRef idx="3">
+            <a:schemeClr val="accent1"/>
+          </a:fillRef>
+          <a:effectRef idx="2">
+            <a:schemeClr val="accent1"/>
+          </a:effectRef>
+          <a:fontRef idx="minor">
+            <a:schemeClr val="lt1"/>
+          </a:fontRef>
+        </p:style>
+        <p:txBody>
+          <a:bodyPr rtlCol="0" anchor="ctr"/>
+          <a:lstStyle/>
+          <a:p>
+            <a:pPr algn="ctr"/>
+          </a:p>
+        </p:txBody>
+      </p:sp>
+      <p:sp>
+        <p:nvSpPr>
+          <p:cNvPr id="13" name="TextBox 12"/>
+          <p:cNvSpPr txBox="1"/>
+          <p:nvPr/>
+        </p:nvSpPr>
+        <p:spPr>
+          <a:xfrm>
+            <a:off x="6350000" y="4495800"/>
+            <a:ext cx="4927600" cy="571500"/>
+          </a:xfrm>
+          <a:prstGeom prst="rect">
+            <a:avLst/>
+          </a:prstGeom>
+          <a:noFill/>
+        </p:spPr>
+        <p:txBody>
+          <a:bodyPr wrap="square" lIns="0" rIns="0" tIns="0" bIns="0" anchor="t">
+            <a:noAutofit/>
+          </a:bodyPr>
+          <a:lstStyle/>
+          <a:p>
+            <a:pPr algn="l">
+              <a:lnSpc>
+                <a:spcPct val="105000"/>
+              </a:lnSpc>
+            </a:pPr>
+            <a:r>
+              <a:rPr sz="3000" b="1">
+                <a:solidFill>
+                  <a:srgbClr val="7AA7FF"/>
+                </a:solidFill>
+                <a:latin typeface="Consolas"/>
+              </a:rPr>
+              <a:t>~500 t CO2 / año</a:t>
+            </a:r>
+          </a:p>
+        </p:txBody>
+      </p:sp>
+      <p:sp>
+        <p:nvSpPr>
+          <p:cNvPr id="14" name="TextBox 13"/>
+          <p:cNvSpPr txBox="1"/>
+          <p:nvPr/>
+        </p:nvSpPr>
+        <p:spPr>
+          <a:xfrm>
+            <a:off x="6350000" y="5181600"/>
+            <a:ext cx="3556000" cy="482600"/>
+          </a:xfrm>
+          <a:prstGeom prst="rect">
+            <a:avLst/>
+          </a:prstGeom>
+          <a:noFill/>
+        </p:spPr>
+        <p:txBody>
+          <a:bodyPr wrap="square" lIns="0" rIns="0" tIns="0" bIns="0" anchor="t">
+            <a:noAutofit/>
+          </a:bodyPr>
+          <a:lstStyle/>
+          <a:p>
+            <a:pPr algn="l">
+              <a:lnSpc>
+                <a:spcPct val="105000"/>
+              </a:lnSpc>
+            </a:pPr>
+            <a:r>
+              <a:rPr sz="2100" b="0">
+                <a:solidFill>
+                  <a:srgbClr val="FFFFFF"/>
+                </a:solidFill>
+                <a:latin typeface="Segoe UI"/>
+              </a:rPr>
+              <a:t>Evitadas por acuerdo.</a:t>
+            </a:r>
+          </a:p>
+        </p:txBody>
+      </p:sp>
+      <p:pic>
+        <p:nvPicPr>
+          <p:cNvPr id="15" name="Picture 14" descr="icon.png"/>
+          <p:cNvPicPr>
+            <a:picLocks noChangeAspect="1"/>
+          </p:cNvPicPr>
+          <p:nvPr/>
+        </p:nvPicPr>
+        <p:blipFill>
+          <a:blip r:embed="rId3"/>
+          <a:srcRect/>
+          <a:stretch>
+            <a:fillRect/>
+          </a:stretch>
+        </p:blipFill>
+        <p:spPr>
+          <a:xfrm>
+            <a:off x="11176000" y="558800"/>
+            <a:ext cx="406400" cy="406400"/>
+          </a:xfrm>
+          <a:prstGeom prst="rect">
+            <a:avLst/>
+          </a:prstGeom>
+        </p:spPr>
+      </p:pic>
+      <p:sp>
+        <p:nvSpPr>
+          <p:cNvPr id="16" name="TextBox 15"/>
+          <p:cNvSpPr txBox="1"/>
+          <p:nvPr/>
+        </p:nvSpPr>
+        <p:spPr>
+          <a:xfrm>
+            <a:off x="10033000" y="5943600"/>
+            <a:ext cx="1549400" cy="342900"/>
+          </a:xfrm>
+          <a:prstGeom prst="rect">
+            <a:avLst/>
+          </a:prstGeom>
+          <a:noFill/>
+        </p:spPr>
+        <p:txBody>
+          <a:bodyPr wrap="square" lIns="0" rIns="0" tIns="0" bIns="0" anchor="t">
+            <a:noAutofit/>
+          </a:bodyPr>
+          <a:lstStyle/>
+          <a:p>
+            <a:pPr algn="r">
+              <a:lnSpc>
+                <a:spcPct val="105000"/>
+              </a:lnSpc>
+            </a:pPr>
+            <a:r>
+              <a:rPr sz="1600" b="1">
+                <a:solidFill>
+                  <a:srgbClr val="5B6B94"/>
+                </a:solidFill>
+                <a:latin typeface="Consolas"/>
+              </a:rPr>
+              <a:t>07 / 08</a:t>
+            </a:r>
+          </a:p>
+        </p:txBody>
+      </p:sp>
+    </p:spTree>
+  </p:cSld>
+  <p:clrMapOvr>
+    <a:masterClrMapping/>
+  </p:clrMapOvr>
+</p:sld>
+</file>
+
+<file path=ppt/slides/slide8.xml><?xml version="1.0" encoding="utf-8"?>
+<p:sld xmlns:a="http://schemas.openxmlformats.org/drawingml/2006/main" xmlns:p="http://schemas.openxmlformats.org/presentationml/2006/main" xmlns:r="http://schemas.openxmlformats.org/officeDocument/2006/relationships">
+  <p:cSld>
+    <p:bg>
+      <p:bgPr>
+        <a:solidFill>
+          <a:srgbClr val="0B1640"/>
+        </a:solidFill>
+        <a:effectLst/>
+      </p:bgPr>
+    </p:bg>
+    <p:spTree>
+      <p:nvGrpSpPr>
+        <p:cNvPr id="1" name=""/>
+        <p:cNvGrpSpPr/>
+        <p:nvPr/>
+      </p:nvGrpSpPr>
+      <p:grpSpPr/>
+      <p:pic>
+        <p:nvPicPr>
+          <p:cNvPr id="2" name="Picture 1" descr="icon.png"/>
+          <p:cNvPicPr>
+            <a:picLocks noChangeAspect="1"/>
+          </p:cNvPicPr>
+          <p:nvPr/>
+        </p:nvPicPr>
+        <p:blipFill>
+          <a:blip r:embed="rId2"/>
+          <a:srcRect/>
+          <a:stretch>
+            <a:fillRect/>
+          </a:stretch>
+        </p:blipFill>
+        <p:spPr>
+          <a:xfrm>
+            <a:off x="660400" y="660400"/>
+            <a:ext cx="711200" cy="711200"/>
+          </a:xfrm>
+          <a:prstGeom prst="rect">
+            <a:avLst/>
+          </a:prstGeom>
+        </p:spPr>
+      </p:pic>
+      <p:sp>
+        <p:nvSpPr>
+          <p:cNvPr id="3" name="TextBox 2"/>
+          <p:cNvSpPr txBox="1"/>
+          <p:nvPr/>
+        </p:nvSpPr>
+        <p:spPr>
+          <a:xfrm>
+            <a:off x="1524000" y="635000"/>
+            <a:ext cx="3556000" cy="889000"/>
+          </a:xfrm>
+          <a:prstGeom prst="rect">
+            <a:avLst/>
+          </a:prstGeom>
+          <a:noFill/>
+        </p:spPr>
+        <p:txBody>
+          <a:bodyPr wrap="square" lIns="0" rIns="0" tIns="0" bIns="0" anchor="t">
+            <a:noAutofit/>
+          </a:bodyPr>
+          <a:lstStyle/>
+          <a:p>
+            <a:pPr algn="l">
+              <a:lnSpc>
+                <a:spcPct val="105000"/>
+              </a:lnSpc>
+            </a:pPr>
+            <a:r>
+              <a:rPr sz="4800" b="1" spc="-96">
+                <a:solidFill>
+                  <a:srgbClr val="FFFFFF"/>
+                </a:solidFill>
+                <a:latin typeface="Segoe UI"/>
+              </a:rPr>
+              <a:t>Sobra</a:t>
+            </a:r>
+            <a:r>
+              <a:rPr sz="4800" b="1" spc="-96">
+                <a:solidFill>
+                  <a:srgbClr val="7AA7FF"/>
+                </a:solidFill>
+                <a:latin typeface="Segoe UI"/>
+              </a:rPr>
+              <a:t>.</a:t>
+            </a:r>
+          </a:p>
+        </p:txBody>
+      </p:sp>
+      <p:sp>
+        <p:nvSpPr>
+          <p:cNvPr id="4" name="TextBox 3"/>
+          <p:cNvSpPr txBox="1"/>
+          <p:nvPr/>
+        </p:nvSpPr>
+        <p:spPr>
+          <a:xfrm>
+            <a:off x="660400" y="1727200"/>
+            <a:ext cx="6858000" cy="1651000"/>
           </a:xfrm>
           <a:prstGeom prst="rect">
             <a:avLst/>
@@ -6284,13 +7242,13 @@
               </a:lnSpc>
             </a:pPr>
             <a:r>
-              <a:rPr sz="2000" b="0">
-                <a:solidFill>
-                  <a:srgbClr val="55605B"/>
-                </a:solidFill>
-                <a:latin typeface="Geist"/>
+              <a:rPr sz="4400" b="1" spc="-88">
+                <a:solidFill>
+                  <a:srgbClr val="FFFFFF"/>
+                </a:solidFill>
+                <a:latin typeface="Segoe UI"/>
               </a:rPr>
-              <a:t>Programado con asistencia de IA. Idea y diseño: Equipo 13.</a:t>
+              <a:t>Con un número</a:t>
             </a:r>
           </a:p>
           <a:p>
@@ -6300,20 +7258,140 @@
               </a:lnSpc>
             </a:pPr>
             <a:r>
+              <a:rPr sz="4400" b="1" spc="-88">
+                <a:solidFill>
+                  <a:srgbClr val="7AA7FF"/>
+                </a:solidFill>
+                <a:latin typeface="Segoe UI"/>
+              </a:rPr>
+              <a:t>que te cierra.</a:t>
+            </a:r>
+          </a:p>
+        </p:txBody>
+      </p:sp>
+      <p:sp>
+        <p:nvSpPr>
+          <p:cNvPr id="5" name="TextBox 4"/>
+          <p:cNvSpPr txBox="1"/>
+          <p:nvPr/>
+        </p:nvSpPr>
+        <p:spPr>
+          <a:xfrm>
+            <a:off x="660400" y="3556000"/>
+            <a:ext cx="6858000" cy="635000"/>
+          </a:xfrm>
+          <a:prstGeom prst="rect">
+            <a:avLst/>
+          </a:prstGeom>
+          <a:noFill/>
+        </p:spPr>
+        <p:txBody>
+          <a:bodyPr wrap="square" lIns="0" rIns="0" tIns="0" bIns="0" anchor="t">
+            <a:noAutofit/>
+          </a:bodyPr>
+          <a:lstStyle/>
+          <a:p>
+            <a:pPr algn="l">
+              <a:lnSpc>
+                <a:spcPct val="105000"/>
+              </a:lnSpc>
+            </a:pPr>
+            <a:r>
+              <a:rPr sz="3000" b="1">
+                <a:solidFill>
+                  <a:srgbClr val="7AA7FF"/>
+                </a:solidFill>
+                <a:latin typeface="Consolas"/>
+                <a:hlinkClick r:id="rId3"/>
+              </a:rPr>
+              <a:t>ideathon-agro-web.vercel.app</a:t>
+            </a:r>
+          </a:p>
+        </p:txBody>
+      </p:sp>
+      <p:sp>
+        <p:nvSpPr>
+          <p:cNvPr id="6" name="TextBox 5"/>
+          <p:cNvSpPr txBox="1"/>
+          <p:nvPr/>
+        </p:nvSpPr>
+        <p:spPr>
+          <a:xfrm>
+            <a:off x="660400" y="4368800"/>
+            <a:ext cx="6858000" cy="482600"/>
+          </a:xfrm>
+          <a:prstGeom prst="rect">
+            <a:avLst/>
+          </a:prstGeom>
+          <a:noFill/>
+        </p:spPr>
+        <p:txBody>
+          <a:bodyPr wrap="square" lIns="0" rIns="0" tIns="0" bIns="0" anchor="t">
+            <a:noAutofit/>
+          </a:bodyPr>
+          <a:lstStyle/>
+          <a:p>
+            <a:pPr algn="l">
+              <a:lnSpc>
+                <a:spcPct val="105000"/>
+              </a:lnSpc>
+            </a:pPr>
+            <a:r>
+              <a:rPr sz="2400" b="1">
+                <a:solidFill>
+                  <a:srgbClr val="FFFFFF"/>
+                </a:solidFill>
+                <a:latin typeface="Segoe UI"/>
+              </a:rPr>
+              <a:t>Equipo 13 · Ideathon NEA Tech 2026</a:t>
+            </a:r>
+          </a:p>
+        </p:txBody>
+      </p:sp>
+      <p:sp>
+        <p:nvSpPr>
+          <p:cNvPr id="7" name="TextBox 6"/>
+          <p:cNvSpPr txBox="1"/>
+          <p:nvPr/>
+        </p:nvSpPr>
+        <p:spPr>
+          <a:xfrm>
+            <a:off x="660400" y="5029200"/>
+            <a:ext cx="6858000" cy="952500"/>
+          </a:xfrm>
+          <a:prstGeom prst="rect">
+            <a:avLst/>
+          </a:prstGeom>
+          <a:noFill/>
+        </p:spPr>
+        <p:txBody>
+          <a:bodyPr wrap="square" lIns="0" rIns="0" tIns="0" bIns="0" anchor="t">
+            <a:noAutofit/>
+          </a:bodyPr>
+          <a:lstStyle/>
+          <a:p>
+            <a:pPr algn="l">
+              <a:lnSpc>
+                <a:spcPct val="115000"/>
+              </a:lnSpc>
+            </a:pPr>
+            <a:r>
               <a:rPr sz="2000" b="0">
                 <a:solidFill>
-                  <a:srgbClr val="55605B"/>
-                </a:solidFill>
-                <a:latin typeface="Geist"/>
+                  <a:srgbClr val="D3DEF3"/>
+                </a:solidFill>
+                <a:latin typeface="Segoe UI"/>
               </a:rPr>
-              <a:t>Componentes previos: no aplica (no reutilizamos desarrollos propios anteriores).</a:t>
+              <a:t>Idea y diseño: Equipo 13. Programación con asistencia de IA. Datos reales con fuente oficial.</a:t>
             </a:r>
           </a:p>
         </p:txBody>
       </p:sp>
       <p:pic>
         <p:nvPicPr>
-          <p:cNvPr id="8" name="Picture 7" descr="icon.png"/>
+          <p:cNvPr id="8" name="Picture 7" descr="qr-demo.png">
+            <a:hlinkClick r:id="rId3"/>
+          </p:cNvPr>
           <p:cNvPicPr>
             <a:picLocks noChangeAspect="1"/>
           </p:cNvPicPr>
@@ -6328,12 +7406,17 @@
         </p:blipFill>
         <p:spPr>
           <a:xfrm>
-            <a:off x="11074400" y="609600"/>
-            <a:ext cx="406400" cy="406400"/>
-          </a:xfrm>
-          <a:prstGeom prst="rect">
-            <a:avLst/>
-          </a:prstGeom>
+            <a:off x="8331200" y="1524000"/>
+            <a:ext cx="3048000" cy="3048000"/>
+          </a:xfrm>
+          <a:prstGeom prst="rect">
+            <a:avLst/>
+          </a:prstGeom>
+          <a:ln w="19050">
+            <a:solidFill>
+              <a:srgbClr val="2150E8"/>
+            </a:solidFill>
+          </a:ln>
         </p:spPr>
       </p:pic>
       <p:sp>
@@ -6344,8 +7427,8 @@
         </p:nvSpPr>
         <p:spPr>
           <a:xfrm>
-            <a:off x="10210800" y="6032500"/>
-            <a:ext cx="1270000" cy="254000"/>
+            <a:off x="8331200" y="4800600"/>
+            <a:ext cx="3048000" cy="457200"/>
           </a:xfrm>
           <a:prstGeom prst="rect">
             <a:avLst/>
@@ -6358,19 +7441,19 @@
           </a:bodyPr>
           <a:lstStyle/>
           <a:p>
-            <a:pPr algn="r">
+            <a:pPr algn="ctr">
               <a:lnSpc>
-                <a:spcPct val="100000"/>
+                <a:spcPct val="105000"/>
               </a:lnSpc>
             </a:pPr>
             <a:r>
-              <a:rPr sz="1400" b="0">
-                <a:solidFill>
-                  <a:srgbClr val="5F6A65"/>
-                </a:solidFill>
-                <a:latin typeface="Geist Mono"/>
+              <a:rPr sz="2000" b="1" spc="80">
+                <a:solidFill>
+                  <a:srgbClr val="7AA7FF"/>
+                </a:solidFill>
+                <a:latin typeface="Consolas"/>
               </a:rPr>
-              <a:t>07 / 07</a:t>
+              <a:t>PROBÁ SOBRA AHORA</a:t>
             </a:r>
           </a:p>
         </p:txBody>

</xml_diff>